<commit_message>
Fix step-card overlap on the path-forward slide, add rendered PDF
Rendering all fifteen slides as a contact sheet showed step 03's heading
running into its description on slide 13 — three lines of heading in a box
sized for two. Headings get a smaller size and more room, descriptions start
lower, and the cards are slightly taller.

Also commits a rendered PDF of the deck so it can be reviewed without
PowerPoint.

Co-Authored-By: Claude Opus 5 <noreply@anthropic.com>
Claude-Session: https://claude.ai/code/session_01WYWPNu6P9u6t1ivaNyJxST
</commit_message>
<xml_diff>
--- a/presentations/finops-gaining-visibility-cfo.pptx
+++ b/presentations/finops-gaining-visibility-cfo.pptx
@@ -6066,11 +6066,11 @@
         <p:spPr>
           <a:xfrm>
             <a:off x="548640" y="1783080"/>
-            <a:ext cx="2587752" cy="2377440"/>
+            <a:ext cx="2587752" cy="2423160"/>
           </a:xfrm>
           <a:prstGeom prst="roundRect">
             <a:avLst>
-              <a:gd name="adj" fmla="val 3462"/>
+              <a:gd name="adj" fmla="val 3396"/>
             </a:avLst>
           </a:prstGeom>
           <a:solidFill>
@@ -6126,8 +6126,8 @@
         </p:nvSpPr>
         <p:spPr>
           <a:xfrm>
-            <a:off x="804672" y="2542032"/>
-            <a:ext cx="2103120" cy="658368"/>
+            <a:off x="786384" y="2523744"/>
+            <a:ext cx="2139696" cy="786384"/>
           </a:xfrm>
           <a:prstGeom prst="rect">
             <a:avLst/>
@@ -6146,7 +6146,7 @@
               <a:buNone/>
             </a:pPr>
             <a:r>
-              <a:rPr lang="en-US" sz="1600" b="1" dirty="0">
+              <a:rPr lang="en-US" sz="1500" b="1" dirty="0">
                 <a:solidFill>
                   <a:srgbClr val="FFFFFF"/>
                 </a:solidFill>
@@ -6156,7 +6156,7 @@
               </a:rPr>
               <a:t>Set the tagging standard</a:t>
             </a:r>
-            <a:endParaRPr lang="en-US" sz="1600" dirty="0"/>
+            <a:endParaRPr lang="en-US" sz="1500" dirty="0"/>
           </a:p>
         </p:txBody>
       </p:sp>
@@ -6168,8 +6168,8 @@
         </p:nvSpPr>
         <p:spPr>
           <a:xfrm>
-            <a:off x="804672" y="3218688"/>
-            <a:ext cx="2103120" cy="822960"/>
+            <a:off x="786384" y="3346704"/>
+            <a:ext cx="2139696" cy="749808"/>
           </a:xfrm>
           <a:prstGeom prst="rect">
             <a:avLst/>
@@ -6211,11 +6211,11 @@
         <p:spPr>
           <a:xfrm>
             <a:off x="3383280" y="1783080"/>
-            <a:ext cx="2587752" cy="2377440"/>
+            <a:ext cx="2587752" cy="2423160"/>
           </a:xfrm>
           <a:prstGeom prst="roundRect">
             <a:avLst>
-              <a:gd name="adj" fmla="val 3462"/>
+              <a:gd name="adj" fmla="val 3396"/>
             </a:avLst>
           </a:prstGeom>
           <a:solidFill>
@@ -6271,8 +6271,8 @@
         </p:nvSpPr>
         <p:spPr>
           <a:xfrm>
-            <a:off x="3639312" y="2542032"/>
-            <a:ext cx="2103120" cy="658368"/>
+            <a:off x="3621024" y="2523744"/>
+            <a:ext cx="2139696" cy="786384"/>
           </a:xfrm>
           <a:prstGeom prst="rect">
             <a:avLst/>
@@ -6291,7 +6291,7 @@
               <a:buNone/>
             </a:pPr>
             <a:r>
-              <a:rPr lang="en-US" sz="1600" b="1" dirty="0">
+              <a:rPr lang="en-US" sz="1500" b="1" dirty="0">
                 <a:solidFill>
                   <a:srgbClr val="1B2430"/>
                 </a:solidFill>
@@ -6301,7 +6301,7 @@
               </a:rPr>
               <a:t>Start with the biggest spend</a:t>
             </a:r>
-            <a:endParaRPr lang="en-US" sz="1600" dirty="0"/>
+            <a:endParaRPr lang="en-US" sz="1500" dirty="0"/>
           </a:p>
         </p:txBody>
       </p:sp>
@@ -6313,8 +6313,8 @@
         </p:nvSpPr>
         <p:spPr>
           <a:xfrm>
-            <a:off x="3639312" y="3218688"/>
-            <a:ext cx="2103120" cy="822960"/>
+            <a:off x="3621024" y="3346704"/>
+            <a:ext cx="2139696" cy="749808"/>
           </a:xfrm>
           <a:prstGeom prst="rect">
             <a:avLst/>
@@ -6356,11 +6356,11 @@
         <p:spPr>
           <a:xfrm>
             <a:off x="6217920" y="1783080"/>
-            <a:ext cx="2587752" cy="2377440"/>
+            <a:ext cx="2587752" cy="2423160"/>
           </a:xfrm>
           <a:prstGeom prst="roundRect">
             <a:avLst>
-              <a:gd name="adj" fmla="val 3462"/>
+              <a:gd name="adj" fmla="val 3396"/>
             </a:avLst>
           </a:prstGeom>
           <a:solidFill>
@@ -6416,8 +6416,8 @@
         </p:nvSpPr>
         <p:spPr>
           <a:xfrm>
-            <a:off x="6473952" y="2542032"/>
-            <a:ext cx="2103120" cy="658368"/>
+            <a:off x="6455664" y="2523744"/>
+            <a:ext cx="2139696" cy="786384"/>
           </a:xfrm>
           <a:prstGeom prst="rect">
             <a:avLst/>
@@ -6436,7 +6436,7 @@
               <a:buNone/>
             </a:pPr>
             <a:r>
-              <a:rPr lang="en-US" sz="1600" b="1" dirty="0">
+              <a:rPr lang="en-US" sz="1500" b="1" dirty="0">
                 <a:solidFill>
                   <a:srgbClr val="1B2430"/>
                 </a:solidFill>
@@ -6446,7 +6446,7 @@
               </a:rPr>
               <a:t>Get finance and engineering talking</a:t>
             </a:r>
-            <a:endParaRPr lang="en-US" sz="1600" dirty="0"/>
+            <a:endParaRPr lang="en-US" sz="1500" dirty="0"/>
           </a:p>
         </p:txBody>
       </p:sp>
@@ -6458,8 +6458,8 @@
         </p:nvSpPr>
         <p:spPr>
           <a:xfrm>
-            <a:off x="6473952" y="3218688"/>
-            <a:ext cx="2103120" cy="822960"/>
+            <a:off x="6455664" y="3346704"/>
+            <a:ext cx="2139696" cy="749808"/>
           </a:xfrm>
           <a:prstGeom prst="rect">
             <a:avLst/>
@@ -6486,7 +6486,7 @@
                 <a:ea typeface="Calibri" pitchFamily="34" charset="-122"/>
                 <a:cs typeface="Calibri" pitchFamily="34" charset="-120"/>
               </a:rPr>
-              <a:t>Bring both into the same conversation early, not as an afterthought.</a:t>
+              <a:t>Bring both into the conversation early, not as an afterthought.</a:t>
             </a:r>
             <a:endParaRPr lang="en-US" sz="1200" dirty="0"/>
           </a:p>
@@ -6501,11 +6501,11 @@
         <p:spPr>
           <a:xfrm>
             <a:off x="9052560" y="1783080"/>
-            <a:ext cx="2587752" cy="2377440"/>
+            <a:ext cx="2587752" cy="2423160"/>
           </a:xfrm>
           <a:prstGeom prst="roundRect">
             <a:avLst>
-              <a:gd name="adj" fmla="val 3462"/>
+              <a:gd name="adj" fmla="val 3396"/>
             </a:avLst>
           </a:prstGeom>
           <a:solidFill>
@@ -6561,8 +6561,8 @@
         </p:nvSpPr>
         <p:spPr>
           <a:xfrm>
-            <a:off x="9308592" y="2542032"/>
-            <a:ext cx="2103120" cy="658368"/>
+            <a:off x="9290304" y="2523744"/>
+            <a:ext cx="2139696" cy="786384"/>
           </a:xfrm>
           <a:prstGeom prst="rect">
             <a:avLst/>
@@ -6581,7 +6581,7 @@
               <a:buNone/>
             </a:pPr>
             <a:r>
-              <a:rPr lang="en-US" sz="1600" b="1" dirty="0">
+              <a:rPr lang="en-US" sz="1500" b="1" dirty="0">
                 <a:solidFill>
                   <a:srgbClr val="1B2430"/>
                 </a:solidFill>
@@ -6591,7 +6591,7 @@
               </a:rPr>
               <a:t>Choose tools that fit the footprint</a:t>
             </a:r>
-            <a:endParaRPr lang="en-US" sz="1600" dirty="0"/>
+            <a:endParaRPr lang="en-US" sz="1500" dirty="0"/>
           </a:p>
         </p:txBody>
       </p:sp>
@@ -6603,8 +6603,8 @@
         </p:nvSpPr>
         <p:spPr>
           <a:xfrm>
-            <a:off x="9308592" y="3218688"/>
-            <a:ext cx="2103120" cy="822960"/>
+            <a:off x="9290304" y="3346704"/>
+            <a:ext cx="2139696" cy="749808"/>
           </a:xfrm>
           <a:prstGeom prst="rect">
             <a:avLst/>

</xml_diff>

<commit_message>
Add "nobody should learn it from the invoice" slide
The deck named sticker shock as the problem on slide 2 and never came back to
it. This is the payoff: one overrun shown at the four moments it could be
found — usage alert in ten minutes, daily threshold next morning, forecast
warning two weeks out, and the invoice a month later with nothing left to
decide. Pairs it with the four conditions that make the early detections
possible, and states the promise the programme can actually keep: not a smaller
invoice, but an invoice holding no surprises.

Co-Authored-By: Claude Opus 5 <noreply@anthropic.com>
Claude-Session: https://claude.ai/code/session_01WYWPNu6P9u6t1ivaNyJxST
</commit_message>
<xml_diff>
--- a/presentations/finops-gaining-visibility-cfo.pptx
+++ b/presentations/finops-gaining-visibility-cfo.pptx
@@ -26,9 +26,10 @@
     <p:sldId id="274" r:id="rId20"/>
     <p:sldId id="275" r:id="rId21"/>
     <p:sldId id="276" r:id="rId22"/>
+    <p:sldId id="277" r:id="rId23"/>
   </p:sldIdLst>
   <p:notesMasterIdLst>
-    <p:notesMasterId r:id="rId23"/>
+    <p:notesMasterId r:id="rId24"/>
   </p:notesMasterIdLst>
   <p:sldSz cx="12192000" cy="6858000"/>
   <p:notesSz cx="6858000" cy="12192000"/>
@@ -1402,7 +1403,7 @@
           <a:p>
             <a:r>
               <a:rPr lang="en-US" dirty="0"/>
-              <a:t>This is the ask, and the honest cost answer is effort rather than licence spend if we stay on native tooling — name the roles and the share of their time instead of quoting a budget number you would have to defend. Step one is the only item that cannot run in parallel: every downstream report degrades if the taxonomy is still moving. Split the ownership explicitly — finance owns the taxonomy, the allocation policy and the KPI definitions; engineering owns enforcement, instrumentation and remediation. Steps two and four are both arguments for restraint: attack the largest cost categories rather than pursuing complete granularity, and buy tooling that matches the estate we have rather than the one we might have in three years.</a:t>
+              <a:t>This is the slide to bring to the conversation about why the number moved, because it reframes the problem from cost to timing. The overrun is the same in all four columns; what changes is how much notice we get, and notice is what converts a write-off into a decision. The third point is the one with direct budget consequence — a forecast warning two weeks before month end can still change the month's outcome, while the invoice can only be explained after close. Be careful with the closing line and repeat it verbatim: this programme does not commit to reducing spend by a percentage, it commits to no unexplained variance. That is the promise we can actually keep, and it is worth more at the audit committee than a savings figure nobody can attribute afterwards.</a:t>
             </a:r>
             <a:endParaRPr lang="en-US" dirty="0"/>
           </a:p>
@@ -1578,7 +1579,7 @@
           <a:p>
             <a:r>
               <a:rPr lang="en-US" dirty="0"/>
-              <a:t>Close on why this sequencing produces a better financial outcome than cutting first. A cut delivers a one-time step down and reverses as soon as attention moves elsewhere; allocation plus ownership changes the rate at which cost is added, which compounds across every subsequent period. That is also the honest framing for the board: the near-term deliverable is explainable variance and a forecast we can stand behind, with targeted savings following the first full period of clean data. Ask for the first two links today — the allocation standard and published ownership — because the rest follow from them and cannot be bought separately.</a:t>
+              <a:t>This is the ask, and the honest cost answer is effort rather than licence spend if we stay on native tooling — name the roles and the share of their time instead of quoting a budget number you would have to defend. Step one is the only item that cannot run in parallel: every downstream report degrades if the taxonomy is still moving. Split the ownership explicitly — finance owns the taxonomy, the allocation policy and the KPI definitions; engineering owns enforcement, instrumentation and remediation. Steps two and four are both arguments for restraint: attack the largest cost categories rather than pursuing complete granularity, and buy tooling that matches the estate we have rather than the one we might have in three years.</a:t>
             </a:r>
             <a:endParaRPr lang="en-US" dirty="0"/>
           </a:p>
@@ -1666,7 +1667,7 @@
           <a:p>
             <a:r>
               <a:rPr lang="en-US" dirty="0"/>
-              <a:t>Expect five questions and have the answers ready. What does it cost: effort, principally, plus any tooling only if we are genuinely multi-cloud. When do savings appear: allocation coverage improves within weeks, targeted savings follow the first full period of clean data, and be careful not to promise a percentage before we can see where the waste is. Who owns it: name the taxonomy owner and the monthly review before leaving the room, or none of this happens. Does it affect the close: better, not worse — daily data improves the accrual, though chargeback adds a journal step worth scoping with the controller. And will chargeback start an internal war: only if we launch it on allocation nobody trusts, which is exactly what the showback runway is for.</a:t>
+              <a:t>Close on why this sequencing produces a better financial outcome than cutting first. A cut delivers a one-time step down and reverses as soon as attention moves elsewhere; allocation plus ownership changes the rate at which cost is added, which compounds across every subsequent period. That is also the honest framing for the board: the near-term deliverable is explainable variance and a forecast we can stand behind, with targeted savings following the first full period of clean data. Ask for the first two links today — the allocation standard and published ownership — because the rest follow from them and cannot be bought separately.</a:t>
             </a:r>
             <a:endParaRPr lang="en-US" dirty="0"/>
           </a:p>
@@ -1690,6 +1691,94 @@
             <a:fld id="{F7021451-1387-4CA6-816F-3879F97B5CBC}" type="slidenum">
               <a:rPr lang="en-US"/>
               <a:t>21</a:t>
+            </a:fld>
+            <a:endParaRPr lang="en-US"/>
+          </a:p>
+        </p:txBody>
+      </p:sp>
+    </p:spTree>
+    <p:extLst>
+      <p:ext uri="{BB962C8B-B14F-4D97-AF65-F5344CB8AC3E}">
+        <p14:creationId xmlns:p14="http://schemas.microsoft.com/office/powerpoint/2010/main" val="1024086991"/>
+      </p:ext>
+    </p:extLst>
+  </p:cSld>
+  <p:clrMapOvr>
+    <a:masterClrMapping/>
+  </p:clrMapOvr>
+</p:notes>
+</file>
+
+<file path=ppt/notesSlides/notesSlide22.xml><?xml version="1.0" encoding="utf-8"?>
+<p:notes xmlns:a="http://schemas.openxmlformats.org/drawingml/2006/main" xmlns:r="http://schemas.openxmlformats.org/officeDocument/2006/relationships" xmlns:p="http://schemas.openxmlformats.org/presentationml/2006/main">
+  <p:cSld>
+    <p:spTree>
+      <p:nvGrpSpPr>
+        <p:cNvPr id="1" name=""/>
+        <p:cNvGrpSpPr/>
+        <p:nvPr/>
+      </p:nvGrpSpPr>
+      <p:grpSpPr>
+        <a:xfrm>
+          <a:off x="0" y="0"/>
+          <a:ext cx="0" cy="0"/>
+          <a:chOff x="0" y="0"/>
+          <a:chExt cx="0" cy="0"/>
+        </a:xfrm>
+      </p:grpSpPr>
+      <p:sp>
+        <p:nvSpPr>
+          <p:cNvPr id="2" name="Slide Image Placeholder 1"/>
+          <p:cNvSpPr>
+            <a:spLocks noGrp="1" noRot="1" noChangeAspect="1"/>
+          </p:cNvSpPr>
+          <p:nvPr>
+            <p:ph type="sldImg"/>
+          </p:nvPr>
+        </p:nvSpPr>
+        <p:spPr/>
+      </p:sp>
+      <p:sp>
+        <p:nvSpPr>
+          <p:cNvPr id="3" name="Notes Placeholder 2"/>
+          <p:cNvSpPr>
+            <a:spLocks noGrp="1"/>
+          </p:cNvSpPr>
+          <p:nvPr>
+            <p:ph type="body" idx="1"/>
+          </p:nvPr>
+        </p:nvSpPr>
+        <p:spPr/>
+        <p:txBody>
+          <a:bodyPr/>
+          <a:lstStyle/>
+          <a:p>
+            <a:r>
+              <a:rPr lang="en-US" dirty="0"/>
+              <a:t>Expect five questions and have the answers ready. What does it cost: effort, principally, plus any tooling only if we are genuinely multi-cloud. When do savings appear: allocation coverage improves within weeks, targeted savings follow the first full period of clean data, and be careful not to promise a percentage before we can see where the waste is. Who owns it: name the taxonomy owner and the monthly review before leaving the room, or none of this happens. Does it affect the close: better, not worse — daily data improves the accrual, though chargeback adds a journal step worth scoping with the controller. And will chargeback start an internal war: only if we launch it on allocation nobody trusts, which is exactly what the showback runway is for.</a:t>
+            </a:r>
+            <a:endParaRPr lang="en-US" dirty="0"/>
+          </a:p>
+        </p:txBody>
+      </p:sp>
+      <p:sp>
+        <p:nvSpPr>
+          <p:cNvPr id="4" name="Slide Number Placeholder 3"/>
+          <p:cNvSpPr>
+            <a:spLocks noGrp="1"/>
+          </p:cNvSpPr>
+          <p:nvPr>
+            <p:ph type="sldNum" sz="quarter" idx="10"/>
+          </p:nvPr>
+        </p:nvSpPr>
+        <p:spPr/>
+        <p:txBody>
+          <a:bodyPr/>
+          <a:lstStyle/>
+          <a:p>
+            <a:fld id="{F7021451-1387-4CA6-816F-3879F97B5CBC}" type="slidenum">
+              <a:rPr lang="en-US"/>
+              <a:t>22</a:t>
             </a:fld>
             <a:endParaRPr lang="en-US"/>
           </a:p>
@@ -12157,7 +12246,7 @@
                 <a:ea typeface="Calibri" pitchFamily="34" charset="-122"/>
                 <a:cs typeface="Calibri" pitchFamily="34" charset="-120"/>
               </a:rPr>
-              <a:t>THE PATH FORWARD</a:t>
+              <a:t>GOVERNANCE — PUTTING IT TOGETHER</a:t>
             </a:r>
             <a:endParaRPr lang="en-US" sz="1100" dirty="0"/>
           </a:p>
@@ -12196,7 +12285,7 @@
                 <a:ea typeface="Cambria" pitchFamily="34" charset="-122"/>
                 <a:cs typeface="Cambria" pitchFamily="34" charset="-120"/>
               </a:rPr>
-              <a:t>Where to start</a:t>
+              <a:t>Nobody should learn it from the invoice</a:t>
             </a:r>
             <a:endParaRPr lang="en-US" sz="3100" dirty="0"/>
           </a:p>
@@ -12204,876 +12293,1145 @@
       </p:sp>
       <p:sp>
         <p:nvSpPr>
-          <p:cNvPr id="4" name="Shape 2"/>
-          <p:cNvSpPr/>
-          <p:nvPr/>
-        </p:nvSpPr>
-        <p:spPr>
-          <a:xfrm>
-            <a:off x="548640" y="1783080"/>
-            <a:ext cx="2587752" cy="2423160"/>
+          <p:cNvPr id="4" name="Text 2"/>
+          <p:cNvSpPr/>
+          <p:nvPr/>
+        </p:nvSpPr>
+        <p:spPr>
+          <a:xfrm>
+            <a:off x="548640" y="1536192"/>
+            <a:ext cx="10607040" cy="365760"/>
+          </a:xfrm>
+          <a:prstGeom prst="rect">
+            <a:avLst/>
+          </a:prstGeom>
+          <a:noFill/>
+          <a:ln/>
+        </p:spPr>
+        <p:txBody>
+          <a:bodyPr wrap="square" lIns="0" tIns="0" rIns="0" bIns="0" rtlCol="0" anchor="ctr"/>
+          <a:lstStyle/>
+          <a:p>
+            <a:pPr indent="0" marL="0">
+              <a:buNone/>
+            </a:pPr>
+            <a:r>
+              <a:rPr lang="en-US" sz="1500" dirty="0">
+                <a:solidFill>
+                  <a:srgbClr val="5C6675"/>
+                </a:solidFill>
+                <a:latin typeface="Calibri" pitchFamily="34" charset="0"/>
+                <a:ea typeface="Calibri" pitchFamily="34" charset="-122"/>
+                <a:cs typeface="Calibri" pitchFamily="34" charset="-120"/>
+              </a:rPr>
+              <a:t>The same overrun, found at four different moments. Only the first three leave you anything to do about it.</a:t>
+            </a:r>
+            <a:endParaRPr lang="en-US" sz="1500" dirty="0"/>
+          </a:p>
+        </p:txBody>
+      </p:sp>
+      <p:sp>
+        <p:nvSpPr>
+          <p:cNvPr id="5" name="Shape 3"/>
+          <p:cNvSpPr/>
+          <p:nvPr/>
+        </p:nvSpPr>
+        <p:spPr>
+          <a:xfrm>
+            <a:off x="1737360" y="3127248"/>
+            <a:ext cx="8714232" cy="45720"/>
           </a:xfrm>
           <a:prstGeom prst="roundRect">
             <a:avLst>
-              <a:gd name="adj" fmla="val 3396"/>
+              <a:gd name="adj" fmla="val 40000"/>
             </a:avLst>
           </a:prstGeom>
           <a:solidFill>
+            <a:srgbClr val="DFE4EA"/>
+          </a:solidFill>
+          <a:ln/>
+        </p:spPr>
+      </p:sp>
+      <p:sp>
+        <p:nvSpPr>
+          <p:cNvPr id="6" name="Text 4"/>
+          <p:cNvSpPr/>
+          <p:nvPr/>
+        </p:nvSpPr>
+        <p:spPr>
+          <a:xfrm>
+            <a:off x="548640" y="2212848"/>
+            <a:ext cx="2377440" cy="310896"/>
+          </a:xfrm>
+          <a:prstGeom prst="rect">
+            <a:avLst/>
+          </a:prstGeom>
+          <a:noFill/>
+          <a:ln/>
+        </p:spPr>
+        <p:txBody>
+          <a:bodyPr wrap="square" lIns="0" tIns="0" rIns="0" bIns="0" rtlCol="0" anchor="ctr"/>
+          <a:lstStyle/>
+          <a:p>
+            <a:pPr algn="ctr" indent="0" marL="0">
+              <a:buNone/>
+            </a:pPr>
+            <a:r>
+              <a:rPr lang="en-US" sz="1400" b="1" dirty="0">
+                <a:solidFill>
+                  <a:srgbClr val="1B2430"/>
+                </a:solidFill>
+                <a:latin typeface="Calibri" pitchFamily="34" charset="0"/>
+                <a:ea typeface="Calibri" pitchFamily="34" charset="-122"/>
+                <a:cs typeface="Calibri" pitchFamily="34" charset="-120"/>
+              </a:rPr>
+              <a:t>Usage burn alert</a:t>
+            </a:r>
+            <a:endParaRPr lang="en-US" sz="1400" dirty="0"/>
+          </a:p>
+        </p:txBody>
+      </p:sp>
+      <p:sp>
+        <p:nvSpPr>
+          <p:cNvPr id="7" name="Text 5"/>
+          <p:cNvSpPr/>
+          <p:nvPr/>
+        </p:nvSpPr>
+        <p:spPr>
+          <a:xfrm>
+            <a:off x="548640" y="2542032"/>
+            <a:ext cx="2377440" cy="292608"/>
+          </a:xfrm>
+          <a:prstGeom prst="rect">
+            <a:avLst/>
+          </a:prstGeom>
+          <a:noFill/>
+          <a:ln/>
+        </p:spPr>
+        <p:txBody>
+          <a:bodyPr wrap="square" lIns="0" tIns="0" rIns="0" bIns="0" rtlCol="0" anchor="ctr"/>
+          <a:lstStyle/>
+          <a:p>
+            <a:pPr algn="ctr" indent="0" marL="0">
+              <a:buNone/>
+            </a:pPr>
+            <a:r>
+              <a:rPr lang="en-US" sz="1250" b="1" spc="60" kern="0" dirty="0">
+                <a:solidFill>
+                  <a:srgbClr val="B87B18"/>
+                </a:solidFill>
+                <a:latin typeface="Calibri" pitchFamily="34" charset="0"/>
+                <a:ea typeface="Calibri" pitchFamily="34" charset="-122"/>
+                <a:cs typeface="Calibri" pitchFamily="34" charset="-120"/>
+              </a:rPr>
+              <a:t>~10 minutes</a:t>
+            </a:r>
+            <a:endParaRPr lang="en-US" sz="1250" dirty="0"/>
+          </a:p>
+        </p:txBody>
+      </p:sp>
+      <p:sp>
+        <p:nvSpPr>
+          <p:cNvPr id="8" name="Shape 6"/>
+          <p:cNvSpPr/>
+          <p:nvPr/>
+        </p:nvSpPr>
+        <p:spPr>
+          <a:xfrm>
+            <a:off x="1618488" y="3031236"/>
+            <a:ext cx="237744" cy="237744"/>
+          </a:xfrm>
+          <a:prstGeom prst="ellipse">
+            <a:avLst/>
+          </a:prstGeom>
+          <a:solidFill>
+            <a:srgbClr val="E39B2C"/>
+          </a:solidFill>
+          <a:ln w="25400">
+            <a:solidFill>
+              <a:srgbClr val="FFFFFF"/>
+            </a:solidFill>
+            <a:prstDash val="solid"/>
+          </a:ln>
+        </p:spPr>
+      </p:sp>
+      <p:sp>
+        <p:nvSpPr>
+          <p:cNvPr id="9" name="Text 7"/>
+          <p:cNvSpPr/>
+          <p:nvPr/>
+        </p:nvSpPr>
+        <p:spPr>
+          <a:xfrm>
+            <a:off x="548640" y="3401568"/>
+            <a:ext cx="2377440" cy="566928"/>
+          </a:xfrm>
+          <a:prstGeom prst="rect">
+            <a:avLst/>
+          </a:prstGeom>
+          <a:noFill/>
+          <a:ln/>
+        </p:spPr>
+        <p:txBody>
+          <a:bodyPr wrap="square" lIns="0" tIns="0" rIns="0" bIns="0" rtlCol="0" anchor="t"/>
+          <a:lstStyle/>
+          <a:p>
+            <a:pPr algn="ctr" indent="0" marL="0">
+              <a:lnSpc>
+                <a:spcPts val="1600"/>
+              </a:lnSpc>
+              <a:buNone/>
+            </a:pPr>
+            <a:r>
+              <a:rPr lang="en-US" sz="1200" dirty="0">
+                <a:solidFill>
+                  <a:srgbClr val="5C6675"/>
+                </a:solidFill>
+                <a:latin typeface="Calibri" pitchFamily="34" charset="0"/>
+                <a:ea typeface="Calibri" pitchFamily="34" charset="-122"/>
+                <a:cs typeface="Calibri" pitchFamily="34" charset="-120"/>
+              </a:rPr>
+              <a:t>Throttle it, or confirm it was intended.</a:t>
+            </a:r>
+            <a:endParaRPr lang="en-US" sz="1200" dirty="0"/>
+          </a:p>
+        </p:txBody>
+      </p:sp>
+      <p:sp>
+        <p:nvSpPr>
+          <p:cNvPr id="10" name="Text 8"/>
+          <p:cNvSpPr/>
+          <p:nvPr/>
+        </p:nvSpPr>
+        <p:spPr>
+          <a:xfrm>
+            <a:off x="3566160" y="2212848"/>
+            <a:ext cx="2377440" cy="310896"/>
+          </a:xfrm>
+          <a:prstGeom prst="rect">
+            <a:avLst/>
+          </a:prstGeom>
+          <a:noFill/>
+          <a:ln/>
+        </p:spPr>
+        <p:txBody>
+          <a:bodyPr wrap="square" lIns="0" tIns="0" rIns="0" bIns="0" rtlCol="0" anchor="ctr"/>
+          <a:lstStyle/>
+          <a:p>
+            <a:pPr algn="ctr" indent="0" marL="0">
+              <a:buNone/>
+            </a:pPr>
+            <a:r>
+              <a:rPr lang="en-US" sz="1400" b="1" dirty="0">
+                <a:solidFill>
+                  <a:srgbClr val="1B2430"/>
+                </a:solidFill>
+                <a:latin typeface="Calibri" pitchFamily="34" charset="0"/>
+                <a:ea typeface="Calibri" pitchFamily="34" charset="-122"/>
+                <a:cs typeface="Calibri" pitchFamily="34" charset="-120"/>
+              </a:rPr>
+              <a:t>Daily spend threshold</a:t>
+            </a:r>
+            <a:endParaRPr lang="en-US" sz="1400" dirty="0"/>
+          </a:p>
+        </p:txBody>
+      </p:sp>
+      <p:sp>
+        <p:nvSpPr>
+          <p:cNvPr id="11" name="Text 9"/>
+          <p:cNvSpPr/>
+          <p:nvPr/>
+        </p:nvSpPr>
+        <p:spPr>
+          <a:xfrm>
+            <a:off x="3566160" y="2542032"/>
+            <a:ext cx="2377440" cy="292608"/>
+          </a:xfrm>
+          <a:prstGeom prst="rect">
+            <a:avLst/>
+          </a:prstGeom>
+          <a:noFill/>
+          <a:ln/>
+        </p:spPr>
+        <p:txBody>
+          <a:bodyPr wrap="square" lIns="0" tIns="0" rIns="0" bIns="0" rtlCol="0" anchor="ctr"/>
+          <a:lstStyle/>
+          <a:p>
+            <a:pPr algn="ctr" indent="0" marL="0">
+              <a:buNone/>
+            </a:pPr>
+            <a:r>
+              <a:rPr lang="en-US" sz="1250" b="1" spc="60" kern="0" dirty="0">
+                <a:solidFill>
+                  <a:srgbClr val="1F6B5C"/>
+                </a:solidFill>
+                <a:latin typeface="Calibri" pitchFamily="34" charset="0"/>
+                <a:ea typeface="Calibri" pitchFamily="34" charset="-122"/>
+                <a:cs typeface="Calibri" pitchFamily="34" charset="-120"/>
+              </a:rPr>
+              <a:t>next morning</a:t>
+            </a:r>
+            <a:endParaRPr lang="en-US" sz="1250" dirty="0"/>
+          </a:p>
+        </p:txBody>
+      </p:sp>
+      <p:sp>
+        <p:nvSpPr>
+          <p:cNvPr id="12" name="Shape 10"/>
+          <p:cNvSpPr/>
+          <p:nvPr/>
+        </p:nvSpPr>
+        <p:spPr>
+          <a:xfrm>
+            <a:off x="4636008" y="3031236"/>
+            <a:ext cx="237744" cy="237744"/>
+          </a:xfrm>
+          <a:prstGeom prst="ellipse">
+            <a:avLst/>
+          </a:prstGeom>
+          <a:solidFill>
+            <a:srgbClr val="2E8B7A"/>
+          </a:solidFill>
+          <a:ln w="25400">
+            <a:solidFill>
+              <a:srgbClr val="FFFFFF"/>
+            </a:solidFill>
+            <a:prstDash val="solid"/>
+          </a:ln>
+        </p:spPr>
+      </p:sp>
+      <p:sp>
+        <p:nvSpPr>
+          <p:cNvPr id="13" name="Text 11"/>
+          <p:cNvSpPr/>
+          <p:nvPr/>
+        </p:nvSpPr>
+        <p:spPr>
+          <a:xfrm>
+            <a:off x="3566160" y="3401568"/>
+            <a:ext cx="2377440" cy="566928"/>
+          </a:xfrm>
+          <a:prstGeom prst="rect">
+            <a:avLst/>
+          </a:prstGeom>
+          <a:noFill/>
+          <a:ln/>
+        </p:spPr>
+        <p:txBody>
+          <a:bodyPr wrap="square" lIns="0" tIns="0" rIns="0" bIns="0" rtlCol="0" anchor="t"/>
+          <a:lstStyle/>
+          <a:p>
+            <a:pPr algn="ctr" indent="0" marL="0">
+              <a:lnSpc>
+                <a:spcPts val="1600"/>
+              </a:lnSpc>
+              <a:buNone/>
+            </a:pPr>
+            <a:r>
+              <a:rPr lang="en-US" sz="1200" dirty="0">
+                <a:solidFill>
+                  <a:srgbClr val="5C6675"/>
+                </a:solidFill>
+                <a:latin typeface="Calibri" pitchFamily="34" charset="0"/>
+                <a:ea typeface="Calibri" pitchFamily="34" charset="-122"/>
+                <a:cs typeface="Calibri" pitchFamily="34" charset="-120"/>
+              </a:rPr>
+              <a:t>One team, one number, one owner to ask.</a:t>
+            </a:r>
+            <a:endParaRPr lang="en-US" sz="1200" dirty="0"/>
+          </a:p>
+        </p:txBody>
+      </p:sp>
+      <p:sp>
+        <p:nvSpPr>
+          <p:cNvPr id="14" name="Text 12"/>
+          <p:cNvSpPr/>
+          <p:nvPr/>
+        </p:nvSpPr>
+        <p:spPr>
+          <a:xfrm>
+            <a:off x="6583680" y="2212848"/>
+            <a:ext cx="2377440" cy="310896"/>
+          </a:xfrm>
+          <a:prstGeom prst="rect">
+            <a:avLst/>
+          </a:prstGeom>
+          <a:noFill/>
+          <a:ln/>
+        </p:spPr>
+        <p:txBody>
+          <a:bodyPr wrap="square" lIns="0" tIns="0" rIns="0" bIns="0" rtlCol="0" anchor="ctr"/>
+          <a:lstStyle/>
+          <a:p>
+            <a:pPr algn="ctr" indent="0" marL="0">
+              <a:buNone/>
+            </a:pPr>
+            <a:r>
+              <a:rPr lang="en-US" sz="1400" b="1" dirty="0">
+                <a:solidFill>
+                  <a:srgbClr val="1B2430"/>
+                </a:solidFill>
+                <a:latin typeface="Calibri" pitchFamily="34" charset="0"/>
+                <a:ea typeface="Calibri" pitchFamily="34" charset="-122"/>
+                <a:cs typeface="Calibri" pitchFamily="34" charset="-120"/>
+              </a:rPr>
+              <a:t>Forecast overrun</a:t>
+            </a:r>
+            <a:endParaRPr lang="en-US" sz="1400" dirty="0"/>
+          </a:p>
+        </p:txBody>
+      </p:sp>
+      <p:sp>
+        <p:nvSpPr>
+          <p:cNvPr id="15" name="Text 13"/>
+          <p:cNvSpPr/>
+          <p:nvPr/>
+        </p:nvSpPr>
+        <p:spPr>
+          <a:xfrm>
+            <a:off x="6583680" y="2542032"/>
+            <a:ext cx="2377440" cy="292608"/>
+          </a:xfrm>
+          <a:prstGeom prst="rect">
+            <a:avLst/>
+          </a:prstGeom>
+          <a:noFill/>
+          <a:ln/>
+        </p:spPr>
+        <p:txBody>
+          <a:bodyPr wrap="square" lIns="0" tIns="0" rIns="0" bIns="0" rtlCol="0" anchor="ctr"/>
+          <a:lstStyle/>
+          <a:p>
+            <a:pPr algn="ctr" indent="0" marL="0">
+              <a:buNone/>
+            </a:pPr>
+            <a:r>
+              <a:rPr lang="en-US" sz="1250" b="1" spc="60" kern="0" dirty="0">
+                <a:solidFill>
+                  <a:srgbClr val="1F6B5C"/>
+                </a:solidFill>
+                <a:latin typeface="Calibri" pitchFamily="34" charset="0"/>
+                <a:ea typeface="Calibri" pitchFamily="34" charset="-122"/>
+                <a:cs typeface="Calibri" pitchFamily="34" charset="-120"/>
+              </a:rPr>
+              <a:t>~2 weeks out</a:t>
+            </a:r>
+            <a:endParaRPr lang="en-US" sz="1250" dirty="0"/>
+          </a:p>
+        </p:txBody>
+      </p:sp>
+      <p:sp>
+        <p:nvSpPr>
+          <p:cNvPr id="16" name="Shape 14"/>
+          <p:cNvSpPr/>
+          <p:nvPr/>
+        </p:nvSpPr>
+        <p:spPr>
+          <a:xfrm>
+            <a:off x="7653528" y="3031236"/>
+            <a:ext cx="237744" cy="237744"/>
+          </a:xfrm>
+          <a:prstGeom prst="ellipse">
+            <a:avLst/>
+          </a:prstGeom>
+          <a:solidFill>
+            <a:srgbClr val="2E8B7A"/>
+          </a:solidFill>
+          <a:ln w="25400">
+            <a:solidFill>
+              <a:srgbClr val="FFFFFF"/>
+            </a:solidFill>
+            <a:prstDash val="solid"/>
+          </a:ln>
+        </p:spPr>
+      </p:sp>
+      <p:sp>
+        <p:nvSpPr>
+          <p:cNvPr id="17" name="Text 15"/>
+          <p:cNvSpPr/>
+          <p:nvPr/>
+        </p:nvSpPr>
+        <p:spPr>
+          <a:xfrm>
+            <a:off x="6583680" y="3401568"/>
+            <a:ext cx="2377440" cy="566928"/>
+          </a:xfrm>
+          <a:prstGeom prst="rect">
+            <a:avLst/>
+          </a:prstGeom>
+          <a:noFill/>
+          <a:ln/>
+        </p:spPr>
+        <p:txBody>
+          <a:bodyPr wrap="square" lIns="0" tIns="0" rIns="0" bIns="0" rtlCol="0" anchor="t"/>
+          <a:lstStyle/>
+          <a:p>
+            <a:pPr algn="ctr" indent="0" marL="0">
+              <a:lnSpc>
+                <a:spcPts val="1600"/>
+              </a:lnSpc>
+              <a:buNone/>
+            </a:pPr>
+            <a:r>
+              <a:rPr lang="en-US" sz="1200" dirty="0">
+                <a:solidFill>
+                  <a:srgbClr val="5C6675"/>
+                </a:solidFill>
+                <a:latin typeface="Calibri" pitchFamily="34" charset="0"/>
+                <a:ea typeface="Calibri" pitchFamily="34" charset="-122"/>
+                <a:cs typeface="Calibri" pitchFamily="34" charset="-120"/>
+              </a:rPr>
+              <a:t>Still time to change the month's outcome.</a:t>
+            </a:r>
+            <a:endParaRPr lang="en-US" sz="1200" dirty="0"/>
+          </a:p>
+        </p:txBody>
+      </p:sp>
+      <p:sp>
+        <p:nvSpPr>
+          <p:cNvPr id="18" name="Text 16"/>
+          <p:cNvSpPr/>
+          <p:nvPr/>
+        </p:nvSpPr>
+        <p:spPr>
+          <a:xfrm>
+            <a:off x="9262872" y="2212848"/>
+            <a:ext cx="2377440" cy="310896"/>
+          </a:xfrm>
+          <a:prstGeom prst="rect">
+            <a:avLst/>
+          </a:prstGeom>
+          <a:noFill/>
+          <a:ln/>
+        </p:spPr>
+        <p:txBody>
+          <a:bodyPr wrap="square" lIns="0" tIns="0" rIns="0" bIns="0" rtlCol="0" anchor="ctr"/>
+          <a:lstStyle/>
+          <a:p>
+            <a:pPr algn="ctr" indent="0" marL="0">
+              <a:buNone/>
+            </a:pPr>
+            <a:r>
+              <a:rPr lang="en-US" sz="1400" b="1" dirty="0">
+                <a:solidFill>
+                  <a:srgbClr val="5C6675"/>
+                </a:solidFill>
+                <a:latin typeface="Calibri" pitchFamily="34" charset="0"/>
+                <a:ea typeface="Calibri" pitchFamily="34" charset="-122"/>
+                <a:cs typeface="Calibri" pitchFamily="34" charset="-120"/>
+              </a:rPr>
+              <a:t>The invoice</a:t>
+            </a:r>
+            <a:endParaRPr lang="en-US" sz="1400" dirty="0"/>
+          </a:p>
+        </p:txBody>
+      </p:sp>
+      <p:sp>
+        <p:nvSpPr>
+          <p:cNvPr id="19" name="Text 17"/>
+          <p:cNvSpPr/>
+          <p:nvPr/>
+        </p:nvSpPr>
+        <p:spPr>
+          <a:xfrm>
+            <a:off x="9262872" y="2542032"/>
+            <a:ext cx="2377440" cy="292608"/>
+          </a:xfrm>
+          <a:prstGeom prst="rect">
+            <a:avLst/>
+          </a:prstGeom>
+          <a:noFill/>
+          <a:ln/>
+        </p:spPr>
+        <p:txBody>
+          <a:bodyPr wrap="square" lIns="0" tIns="0" rIns="0" bIns="0" rtlCol="0" anchor="ctr"/>
+          <a:lstStyle/>
+          <a:p>
+            <a:pPr algn="ctr" indent="0" marL="0">
+              <a:buNone/>
+            </a:pPr>
+            <a:r>
+              <a:rPr lang="en-US" sz="1250" b="1" spc="60" kern="0" dirty="0">
+                <a:solidFill>
+                  <a:srgbClr val="5C6675"/>
+                </a:solidFill>
+                <a:latin typeface="Calibri" pitchFamily="34" charset="0"/>
+                <a:ea typeface="Calibri" pitchFamily="34" charset="-122"/>
+                <a:cs typeface="Calibri" pitchFamily="34" charset="-120"/>
+              </a:rPr>
+              <a:t>30–45 days later</a:t>
+            </a:r>
+            <a:endParaRPr lang="en-US" sz="1250" dirty="0"/>
+          </a:p>
+        </p:txBody>
+      </p:sp>
+      <p:sp>
+        <p:nvSpPr>
+          <p:cNvPr id="20" name="Shape 18"/>
+          <p:cNvSpPr/>
+          <p:nvPr/>
+        </p:nvSpPr>
+        <p:spPr>
+          <a:xfrm>
+            <a:off x="10332720" y="3031236"/>
+            <a:ext cx="237744" cy="237744"/>
+          </a:xfrm>
+          <a:prstGeom prst="ellipse">
+            <a:avLst/>
+          </a:prstGeom>
+          <a:solidFill>
+            <a:srgbClr val="AEB8C4"/>
+          </a:solidFill>
+          <a:ln w="25400">
+            <a:solidFill>
+              <a:srgbClr val="FFFFFF"/>
+            </a:solidFill>
+            <a:prstDash val="solid"/>
+          </a:ln>
+        </p:spPr>
+      </p:sp>
+      <p:sp>
+        <p:nvSpPr>
+          <p:cNvPr id="21" name="Text 19"/>
+          <p:cNvSpPr/>
+          <p:nvPr/>
+        </p:nvSpPr>
+        <p:spPr>
+          <a:xfrm>
+            <a:off x="9262872" y="3401568"/>
+            <a:ext cx="2377440" cy="566928"/>
+          </a:xfrm>
+          <a:prstGeom prst="rect">
+            <a:avLst/>
+          </a:prstGeom>
+          <a:noFill/>
+          <a:ln/>
+        </p:spPr>
+        <p:txBody>
+          <a:bodyPr wrap="square" lIns="0" tIns="0" rIns="0" bIns="0" rtlCol="0" anchor="t"/>
+          <a:lstStyle/>
+          <a:p>
+            <a:pPr algn="ctr" indent="0" marL="0">
+              <a:lnSpc>
+                <a:spcPts val="1600"/>
+              </a:lnSpc>
+              <a:buNone/>
+            </a:pPr>
+            <a:r>
+              <a:rPr lang="en-US" sz="1200" dirty="0">
+                <a:solidFill>
+                  <a:srgbClr val="5C6675"/>
+                </a:solidFill>
+                <a:latin typeface="Calibri" pitchFamily="34" charset="0"/>
+                <a:ea typeface="Calibri" pitchFamily="34" charset="-122"/>
+                <a:cs typeface="Calibri" pitchFamily="34" charset="-120"/>
+              </a:rPr>
+              <a:t>Nothing left to decide. Only to explain.</a:t>
+            </a:r>
+            <a:endParaRPr lang="en-US" sz="1200" dirty="0"/>
+          </a:p>
+        </p:txBody>
+      </p:sp>
+      <p:sp>
+        <p:nvSpPr>
+          <p:cNvPr id="22" name="Shape 20"/>
+          <p:cNvSpPr/>
+          <p:nvPr/>
+        </p:nvSpPr>
+        <p:spPr>
+          <a:xfrm>
+            <a:off x="548640" y="4297680"/>
+            <a:ext cx="6675120" cy="2011680"/>
+          </a:xfrm>
+          <a:prstGeom prst="roundRect">
+            <a:avLst>
+              <a:gd name="adj" fmla="val 4091"/>
+            </a:avLst>
+          </a:prstGeom>
+          <a:solidFill>
+            <a:srgbClr val="F1F3F6"/>
+          </a:solidFill>
+          <a:ln/>
+        </p:spPr>
+      </p:sp>
+      <p:sp>
+        <p:nvSpPr>
+          <p:cNvPr id="23" name="Text 21"/>
+          <p:cNvSpPr/>
+          <p:nvPr/>
+        </p:nvSpPr>
+        <p:spPr>
+          <a:xfrm>
+            <a:off x="877824" y="4443984"/>
+            <a:ext cx="3657600" cy="292608"/>
+          </a:xfrm>
+          <a:prstGeom prst="rect">
+            <a:avLst/>
+          </a:prstGeom>
+          <a:noFill/>
+          <a:ln/>
+        </p:spPr>
+        <p:txBody>
+          <a:bodyPr wrap="square" lIns="0" tIns="0" rIns="0" bIns="0" rtlCol="0" anchor="ctr"/>
+          <a:lstStyle/>
+          <a:p>
+            <a:pPr indent="0" marL="0">
+              <a:buNone/>
+            </a:pPr>
+            <a:r>
+              <a:rPr lang="en-US" sz="1200" b="1" spc="180" kern="0" dirty="0">
+                <a:solidFill>
+                  <a:srgbClr val="5C6675"/>
+                </a:solidFill>
+                <a:latin typeface="Calibri" pitchFamily="34" charset="0"/>
+                <a:ea typeface="Calibri" pitchFamily="34" charset="-122"/>
+                <a:cs typeface="Calibri" pitchFamily="34" charset="-120"/>
+              </a:rPr>
+              <a:t>What has to be true</a:t>
+            </a:r>
+            <a:endParaRPr lang="en-US" sz="1200" dirty="0"/>
+          </a:p>
+        </p:txBody>
+      </p:sp>
+      <p:sp>
+        <p:nvSpPr>
+          <p:cNvPr id="24" name="Shape 22"/>
+          <p:cNvSpPr/>
+          <p:nvPr/>
+        </p:nvSpPr>
+        <p:spPr>
+          <a:xfrm>
+            <a:off x="877824" y="4809744"/>
+            <a:ext cx="274320" cy="274320"/>
+          </a:xfrm>
+          <a:prstGeom prst="ellipse">
+            <a:avLst/>
+          </a:prstGeom>
+          <a:solidFill>
+            <a:srgbClr val="FFFFFF"/>
+          </a:solidFill>
+          <a:ln/>
+        </p:spPr>
+      </p:sp>
+      <p:pic>
+        <p:nvPicPr>
+          <p:cNvPr id="25" name="Image 0" descr="preencoded.png">    </p:cNvPr>
+          <p:cNvPicPr>
+            <a:picLocks noChangeAspect="1"/>
+          </p:cNvPicPr>
+          <p:nvPr/>
+        </p:nvPicPr>
+        <p:blipFill>
+          <a:blip r:embed="rId1"/>
+          <a:stretch>
+            <a:fillRect/>
+          </a:stretch>
+        </p:blipFill>
+        <p:spPr>
+          <a:xfrm>
+            <a:off x="946404" y="4878324"/>
+            <a:ext cx="137160" cy="137160"/>
+          </a:xfrm>
+          <a:prstGeom prst="rect">
+            <a:avLst/>
+          </a:prstGeom>
+        </p:spPr>
+      </p:pic>
+      <p:sp>
+        <p:nvSpPr>
+          <p:cNvPr id="26" name="Text 23"/>
+          <p:cNvSpPr/>
+          <p:nvPr/>
+        </p:nvSpPr>
+        <p:spPr>
+          <a:xfrm>
+            <a:off x="1298448" y="4754880"/>
+            <a:ext cx="5669280" cy="384048"/>
+          </a:xfrm>
+          <a:prstGeom prst="rect">
+            <a:avLst/>
+          </a:prstGeom>
+          <a:noFill/>
+          <a:ln/>
+        </p:spPr>
+        <p:txBody>
+          <a:bodyPr wrap="square" lIns="0" tIns="0" rIns="0" bIns="0" rtlCol="0" anchor="ctr"/>
+          <a:lstStyle/>
+          <a:p>
+            <a:pPr indent="0" marL="0">
+              <a:buNone/>
+            </a:pPr>
+            <a:r>
+              <a:rPr lang="en-US" sz="1300" dirty="0">
+                <a:solidFill>
+                  <a:srgbClr val="1B2430"/>
+                </a:solidFill>
+                <a:latin typeface="Calibri" pitchFamily="34" charset="0"/>
+                <a:ea typeface="Calibri" pitchFamily="34" charset="-122"/>
+                <a:cs typeface="Calibri" pitchFamily="34" charset="-120"/>
+              </a:rPr>
+              <a:t>Protective alerts run on usage data, not on billing data</a:t>
+            </a:r>
+            <a:endParaRPr lang="en-US" sz="1300" dirty="0"/>
+          </a:p>
+        </p:txBody>
+      </p:sp>
+      <p:sp>
+        <p:nvSpPr>
+          <p:cNvPr id="27" name="Shape 24"/>
+          <p:cNvSpPr/>
+          <p:nvPr/>
+        </p:nvSpPr>
+        <p:spPr>
+          <a:xfrm>
+            <a:off x="877824" y="5193792"/>
+            <a:ext cx="274320" cy="274320"/>
+          </a:xfrm>
+          <a:prstGeom prst="ellipse">
+            <a:avLst/>
+          </a:prstGeom>
+          <a:solidFill>
+            <a:srgbClr val="FFFFFF"/>
+          </a:solidFill>
+          <a:ln/>
+        </p:spPr>
+      </p:sp>
+      <p:pic>
+        <p:nvPicPr>
+          <p:cNvPr id="28" name="Image 1" descr="preencoded.png">    </p:cNvPr>
+          <p:cNvPicPr>
+            <a:picLocks noChangeAspect="1"/>
+          </p:cNvPicPr>
+          <p:nvPr/>
+        </p:nvPicPr>
+        <p:blipFill>
+          <a:blip r:embed="rId2"/>
+          <a:stretch>
+            <a:fillRect/>
+          </a:stretch>
+        </p:blipFill>
+        <p:spPr>
+          <a:xfrm>
+            <a:off x="946404" y="5262372"/>
+            <a:ext cx="137160" cy="137160"/>
+          </a:xfrm>
+          <a:prstGeom prst="rect">
+            <a:avLst/>
+          </a:prstGeom>
+        </p:spPr>
+      </p:pic>
+      <p:sp>
+        <p:nvSpPr>
+          <p:cNvPr id="29" name="Text 25"/>
+          <p:cNvSpPr/>
+          <p:nvPr/>
+        </p:nvSpPr>
+        <p:spPr>
+          <a:xfrm>
+            <a:off x="1298448" y="5138928"/>
+            <a:ext cx="5669280" cy="384048"/>
+          </a:xfrm>
+          <a:prstGeom prst="rect">
+            <a:avLst/>
+          </a:prstGeom>
+          <a:noFill/>
+          <a:ln/>
+        </p:spPr>
+        <p:txBody>
+          <a:bodyPr wrap="square" lIns="0" tIns="0" rIns="0" bIns="0" rtlCol="0" anchor="ctr"/>
+          <a:lstStyle/>
+          <a:p>
+            <a:pPr indent="0" marL="0">
+              <a:buNone/>
+            </a:pPr>
+            <a:r>
+              <a:rPr lang="en-US" sz="1300" dirty="0">
+                <a:solidFill>
+                  <a:srgbClr val="1B2430"/>
+                </a:solidFill>
+                <a:latin typeface="Calibri" pitchFamily="34" charset="0"/>
+                <a:ea typeface="Calibri" pitchFamily="34" charset="-122"/>
+                <a:cs typeface="Calibri" pitchFamily="34" charset="-120"/>
+              </a:rPr>
+              <a:t>Every alert has a named owner to route to</a:t>
+            </a:r>
+            <a:endParaRPr lang="en-US" sz="1300" dirty="0"/>
+          </a:p>
+        </p:txBody>
+      </p:sp>
+      <p:sp>
+        <p:nvSpPr>
+          <p:cNvPr id="30" name="Shape 26"/>
+          <p:cNvSpPr/>
+          <p:nvPr/>
+        </p:nvSpPr>
+        <p:spPr>
+          <a:xfrm>
+            <a:off x="877824" y="5577840"/>
+            <a:ext cx="274320" cy="274320"/>
+          </a:xfrm>
+          <a:prstGeom prst="ellipse">
+            <a:avLst/>
+          </a:prstGeom>
+          <a:solidFill>
+            <a:srgbClr val="FFFFFF"/>
+          </a:solidFill>
+          <a:ln/>
+        </p:spPr>
+      </p:sp>
+      <p:pic>
+        <p:nvPicPr>
+          <p:cNvPr id="31" name="Image 2" descr="preencoded.png">    </p:cNvPr>
+          <p:cNvPicPr>
+            <a:picLocks noChangeAspect="1"/>
+          </p:cNvPicPr>
+          <p:nvPr/>
+        </p:nvPicPr>
+        <p:blipFill>
+          <a:blip r:embed="rId3"/>
+          <a:stretch>
+            <a:fillRect/>
+          </a:stretch>
+        </p:blipFill>
+        <p:spPr>
+          <a:xfrm>
+            <a:off x="946404" y="5646420"/>
+            <a:ext cx="137160" cy="137160"/>
+          </a:xfrm>
+          <a:prstGeom prst="rect">
+            <a:avLst/>
+          </a:prstGeom>
+        </p:spPr>
+      </p:pic>
+      <p:sp>
+        <p:nvSpPr>
+          <p:cNvPr id="32" name="Text 27"/>
+          <p:cNvSpPr/>
+          <p:nvPr/>
+        </p:nvSpPr>
+        <p:spPr>
+          <a:xfrm>
+            <a:off x="1298448" y="5522976"/>
+            <a:ext cx="5669280" cy="384048"/>
+          </a:xfrm>
+          <a:prstGeom prst="rect">
+            <a:avLst/>
+          </a:prstGeom>
+          <a:noFill/>
+          <a:ln/>
+        </p:spPr>
+        <p:txBody>
+          <a:bodyPr wrap="square" lIns="0" tIns="0" rIns="0" bIns="0" rtlCol="0" anchor="ctr"/>
+          <a:lstStyle/>
+          <a:p>
+            <a:pPr indent="0" marL="0">
+              <a:buNone/>
+            </a:pPr>
+            <a:r>
+              <a:rPr lang="en-US" sz="1300" dirty="0">
+                <a:solidFill>
+                  <a:srgbClr val="1B2430"/>
+                </a:solidFill>
+                <a:latin typeface="Calibri" pitchFamily="34" charset="0"/>
+                <a:ea typeface="Calibri" pitchFamily="34" charset="-122"/>
+                <a:cs typeface="Calibri" pitchFamily="34" charset="-120"/>
+              </a:rPr>
+              <a:t>Budgets are phased, so drift shows up in week one</a:t>
+            </a:r>
+            <a:endParaRPr lang="en-US" sz="1300" dirty="0"/>
+          </a:p>
+        </p:txBody>
+      </p:sp>
+      <p:sp>
+        <p:nvSpPr>
+          <p:cNvPr id="33" name="Shape 28"/>
+          <p:cNvSpPr/>
+          <p:nvPr/>
+        </p:nvSpPr>
+        <p:spPr>
+          <a:xfrm>
+            <a:off x="877824" y="5961888"/>
+            <a:ext cx="274320" cy="274320"/>
+          </a:xfrm>
+          <a:prstGeom prst="ellipse">
+            <a:avLst/>
+          </a:prstGeom>
+          <a:solidFill>
+            <a:srgbClr val="FFFFFF"/>
+          </a:solidFill>
+          <a:ln/>
+        </p:spPr>
+      </p:sp>
+      <p:pic>
+        <p:nvPicPr>
+          <p:cNvPr id="34" name="Image 3" descr="preencoded.png">    </p:cNvPr>
+          <p:cNvPicPr>
+            <a:picLocks noChangeAspect="1"/>
+          </p:cNvPicPr>
+          <p:nvPr/>
+        </p:nvPicPr>
+        <p:blipFill>
+          <a:blip r:embed="rId4"/>
+          <a:stretch>
+            <a:fillRect/>
+          </a:stretch>
+        </p:blipFill>
+        <p:spPr>
+          <a:xfrm>
+            <a:off x="946404" y="6030468"/>
+            <a:ext cx="137160" cy="137160"/>
+          </a:xfrm>
+          <a:prstGeom prst="rect">
+            <a:avLst/>
+          </a:prstGeom>
+        </p:spPr>
+      </p:pic>
+      <p:sp>
+        <p:nvSpPr>
+          <p:cNvPr id="35" name="Text 29"/>
+          <p:cNvSpPr/>
+          <p:nvPr/>
+        </p:nvSpPr>
+        <p:spPr>
+          <a:xfrm>
+            <a:off x="1298448" y="5907024"/>
+            <a:ext cx="5669280" cy="384048"/>
+          </a:xfrm>
+          <a:prstGeom prst="rect">
+            <a:avLst/>
+          </a:prstGeom>
+          <a:noFill/>
+          <a:ln/>
+        </p:spPr>
+        <p:txBody>
+          <a:bodyPr wrap="square" lIns="0" tIns="0" rIns="0" bIns="0" rtlCol="0" anchor="ctr"/>
+          <a:lstStyle/>
+          <a:p>
+            <a:pPr indent="0" marL="0">
+              <a:buNone/>
+            </a:pPr>
+            <a:r>
+              <a:rPr lang="en-US" sz="1300" dirty="0">
+                <a:solidFill>
+                  <a:srgbClr val="1B2430"/>
+                </a:solidFill>
+                <a:latin typeface="Calibri" pitchFamily="34" charset="0"/>
+                <a:ea typeface="Calibri" pitchFamily="34" charset="-122"/>
+                <a:cs typeface="Calibri" pitchFamily="34" charset="-120"/>
+              </a:rPr>
+              <a:t>Quotas cap the worst case while someone investigates</a:t>
+            </a:r>
+            <a:endParaRPr lang="en-US" sz="1300" dirty="0"/>
+          </a:p>
+        </p:txBody>
+      </p:sp>
+      <p:sp>
+        <p:nvSpPr>
+          <p:cNvPr id="36" name="Shape 30"/>
+          <p:cNvSpPr/>
+          <p:nvPr/>
+        </p:nvSpPr>
+        <p:spPr>
+          <a:xfrm>
+            <a:off x="7525512" y="4297680"/>
+            <a:ext cx="4114800" cy="2011680"/>
+          </a:xfrm>
+          <a:prstGeom prst="roundRect">
+            <a:avLst>
+              <a:gd name="adj" fmla="val 4091"/>
+            </a:avLst>
+          </a:prstGeom>
+          <a:solidFill>
             <a:srgbClr val="1F2936"/>
           </a:solidFill>
           <a:ln/>
-        </p:spPr>
-      </p:sp>
-      <p:sp>
-        <p:nvSpPr>
-          <p:cNvPr id="5" name="Text 3"/>
-          <p:cNvSpPr/>
-          <p:nvPr/>
-        </p:nvSpPr>
-        <p:spPr>
-          <a:xfrm>
-            <a:off x="804672" y="1965960"/>
-            <a:ext cx="1097280" cy="502920"/>
-          </a:xfrm>
-          <a:prstGeom prst="rect">
-            <a:avLst/>
-          </a:prstGeom>
-          <a:noFill/>
-          <a:ln/>
-        </p:spPr>
-        <p:txBody>
-          <a:bodyPr wrap="square" lIns="0" tIns="0" rIns="0" bIns="0" rtlCol="0" anchor="ctr"/>
-          <a:lstStyle/>
-          <a:p>
-            <a:pPr indent="0" marL="0">
-              <a:buNone/>
-            </a:pPr>
-            <a:r>
-              <a:rPr lang="en-US" sz="2800" b="1" dirty="0">
+          <a:effectLst>
+            <a:outerShdw sx="100000" sy="100000" kx="0" ky="0" algn="bl" rotWithShape="0" blurRad="127000" dist="25400" dir="5400000">
+              <a:srgbClr val="8C99A8">
+                <a:alpha val="16000"/>
+              </a:srgbClr>
+            </a:outerShdw>
+          </a:effectLst>
+        </p:spPr>
+      </p:sp>
+      <p:sp>
+        <p:nvSpPr>
+          <p:cNvPr id="37" name="Text 31"/>
+          <p:cNvSpPr/>
+          <p:nvPr/>
+        </p:nvSpPr>
+        <p:spPr>
+          <a:xfrm>
+            <a:off x="7818120" y="4462272"/>
+            <a:ext cx="3200400" cy="292608"/>
+          </a:xfrm>
+          <a:prstGeom prst="rect">
+            <a:avLst/>
+          </a:prstGeom>
+          <a:noFill/>
+          <a:ln/>
+        </p:spPr>
+        <p:txBody>
+          <a:bodyPr wrap="square" lIns="0" tIns="0" rIns="0" bIns="0" rtlCol="0" anchor="ctr"/>
+          <a:lstStyle/>
+          <a:p>
+            <a:pPr indent="0" marL="0">
+              <a:buNone/>
+            </a:pPr>
+            <a:r>
+              <a:rPr lang="en-US" sz="1200" b="1" spc="180" kern="0" dirty="0">
                 <a:solidFill>
                   <a:srgbClr val="E39B2C"/>
+                </a:solidFill>
+                <a:latin typeface="Calibri" pitchFamily="34" charset="0"/>
+                <a:ea typeface="Calibri" pitchFamily="34" charset="-122"/>
+                <a:cs typeface="Calibri" pitchFamily="34" charset="-120"/>
+              </a:rPr>
+              <a:t>The point</a:t>
+            </a:r>
+            <a:endParaRPr lang="en-US" sz="1200" dirty="0"/>
+          </a:p>
+        </p:txBody>
+      </p:sp>
+      <p:sp>
+        <p:nvSpPr>
+          <p:cNvPr id="38" name="Text 32"/>
+          <p:cNvSpPr/>
+          <p:nvPr/>
+        </p:nvSpPr>
+        <p:spPr>
+          <a:xfrm>
+            <a:off x="7818120" y="4828032"/>
+            <a:ext cx="3529584" cy="1280160"/>
+          </a:xfrm>
+          <a:prstGeom prst="rect">
+            <a:avLst/>
+          </a:prstGeom>
+          <a:noFill/>
+          <a:ln/>
+        </p:spPr>
+        <p:txBody>
+          <a:bodyPr wrap="square" lIns="0" tIns="0" rIns="0" bIns="0" rtlCol="0" anchor="t"/>
+          <a:lstStyle/>
+          <a:p>
+            <a:pPr indent="0" marL="0">
+              <a:lnSpc>
+                <a:spcPts val="2200"/>
+              </a:lnSpc>
+              <a:buNone/>
+            </a:pPr>
+            <a:r>
+              <a:rPr lang="en-US" sz="1550" i="1" dirty="0">
+                <a:solidFill>
+                  <a:srgbClr val="FFFFFF"/>
                 </a:solidFill>
                 <a:latin typeface="Cambria" pitchFamily="34" charset="0"/>
                 <a:ea typeface="Cambria" pitchFamily="34" charset="-122"/>
                 <a:cs typeface="Cambria" pitchFamily="34" charset="-120"/>
               </a:rPr>
-              <a:t>01</a:t>
-            </a:r>
-            <a:endParaRPr lang="en-US" sz="2800" dirty="0"/>
-          </a:p>
-        </p:txBody>
-      </p:sp>
-      <p:sp>
-        <p:nvSpPr>
-          <p:cNvPr id="6" name="Text 4"/>
-          <p:cNvSpPr/>
-          <p:nvPr/>
-        </p:nvSpPr>
-        <p:spPr>
-          <a:xfrm>
-            <a:off x="786384" y="2523744"/>
-            <a:ext cx="2139696" cy="786384"/>
-          </a:xfrm>
-          <a:prstGeom prst="rect">
-            <a:avLst/>
-          </a:prstGeom>
-          <a:noFill/>
-          <a:ln/>
-        </p:spPr>
-        <p:txBody>
-          <a:bodyPr wrap="square" lIns="0" tIns="0" rIns="0" bIns="0" rtlCol="0" anchor="t"/>
-          <a:lstStyle/>
-          <a:p>
-            <a:pPr indent="0" marL="0">
-              <a:lnSpc>
-                <a:spcPts val="2000"/>
-              </a:lnSpc>
-              <a:buNone/>
-            </a:pPr>
-            <a:r>
-              <a:rPr lang="en-US" sz="1500" b="1" dirty="0">
-                <a:solidFill>
-                  <a:srgbClr val="FFFFFF"/>
-                </a:solidFill>
-                <a:latin typeface="Cambria" pitchFamily="34" charset="0"/>
-                <a:ea typeface="Cambria" pitchFamily="34" charset="-122"/>
-                <a:cs typeface="Cambria" pitchFamily="34" charset="-120"/>
-              </a:rPr>
-              <a:t>Set the tagging standard</a:t>
-            </a:r>
-            <a:endParaRPr lang="en-US" sz="1500" dirty="0"/>
-          </a:p>
-        </p:txBody>
-      </p:sp>
-      <p:sp>
-        <p:nvSpPr>
-          <p:cNvPr id="7" name="Text 5"/>
-          <p:cNvSpPr/>
-          <p:nvPr/>
-        </p:nvSpPr>
-        <p:spPr>
-          <a:xfrm>
-            <a:off x="786384" y="3346704"/>
-            <a:ext cx="2139696" cy="749808"/>
-          </a:xfrm>
-          <a:prstGeom prst="rect">
-            <a:avLst/>
-          </a:prstGeom>
-          <a:noFill/>
-          <a:ln/>
-        </p:spPr>
-        <p:txBody>
-          <a:bodyPr wrap="square" lIns="0" tIns="0" rIns="0" bIns="0" rtlCol="0" anchor="t"/>
-          <a:lstStyle/>
-          <a:p>
-            <a:pPr indent="0" marL="0">
-              <a:lnSpc>
-                <a:spcPts val="1500"/>
-              </a:lnSpc>
-              <a:buNone/>
-            </a:pPr>
-            <a:r>
-              <a:rPr lang="en-US" sz="1200" dirty="0">
-                <a:solidFill>
-                  <a:srgbClr val="9EABBA"/>
-                </a:solidFill>
-                <a:latin typeface="Calibri" pitchFamily="34" charset="0"/>
-                <a:ea typeface="Calibri" pitchFamily="34" charset="-122"/>
-                <a:cs typeface="Calibri" pitchFamily="34" charset="-120"/>
-              </a:rPr>
-              <a:t>Agree a consistent taxonomy before investing in dashboards.</a:t>
-            </a:r>
-            <a:endParaRPr lang="en-US" sz="1200" dirty="0"/>
-          </a:p>
-        </p:txBody>
-      </p:sp>
-      <p:sp>
-        <p:nvSpPr>
-          <p:cNvPr id="8" name="Shape 6"/>
-          <p:cNvSpPr/>
-          <p:nvPr/>
-        </p:nvSpPr>
-        <p:spPr>
-          <a:xfrm>
-            <a:off x="3383280" y="1783080"/>
-            <a:ext cx="2587752" cy="2423160"/>
-          </a:xfrm>
-          <a:prstGeom prst="roundRect">
-            <a:avLst>
-              <a:gd name="adj" fmla="val 3396"/>
-            </a:avLst>
-          </a:prstGeom>
-          <a:solidFill>
-            <a:srgbClr val="F1F3F6"/>
-          </a:solidFill>
-          <a:ln/>
-        </p:spPr>
-      </p:sp>
-      <p:sp>
-        <p:nvSpPr>
-          <p:cNvPr id="9" name="Text 7"/>
-          <p:cNvSpPr/>
-          <p:nvPr/>
-        </p:nvSpPr>
-        <p:spPr>
-          <a:xfrm>
-            <a:off x="3639312" y="1965960"/>
-            <a:ext cx="1097280" cy="502920"/>
-          </a:xfrm>
-          <a:prstGeom prst="rect">
-            <a:avLst/>
-          </a:prstGeom>
-          <a:noFill/>
-          <a:ln/>
-        </p:spPr>
-        <p:txBody>
-          <a:bodyPr wrap="square" lIns="0" tIns="0" rIns="0" bIns="0" rtlCol="0" anchor="ctr"/>
-          <a:lstStyle/>
-          <a:p>
-            <a:pPr indent="0" marL="0">
-              <a:buNone/>
-            </a:pPr>
-            <a:r>
-              <a:rPr lang="en-US" sz="2800" b="1" dirty="0">
-                <a:solidFill>
-                  <a:srgbClr val="B9C2CD"/>
-                </a:solidFill>
-                <a:latin typeface="Cambria" pitchFamily="34" charset="0"/>
-                <a:ea typeface="Cambria" pitchFamily="34" charset="-122"/>
-                <a:cs typeface="Cambria" pitchFamily="34" charset="-120"/>
-              </a:rPr>
-              <a:t>02</a:t>
-            </a:r>
-            <a:endParaRPr lang="en-US" sz="2800" dirty="0"/>
-          </a:p>
-        </p:txBody>
-      </p:sp>
-      <p:sp>
-        <p:nvSpPr>
-          <p:cNvPr id="10" name="Text 8"/>
-          <p:cNvSpPr/>
-          <p:nvPr/>
-        </p:nvSpPr>
-        <p:spPr>
-          <a:xfrm>
-            <a:off x="3621024" y="2523744"/>
-            <a:ext cx="2139696" cy="786384"/>
-          </a:xfrm>
-          <a:prstGeom prst="rect">
-            <a:avLst/>
-          </a:prstGeom>
-          <a:noFill/>
-          <a:ln/>
-        </p:spPr>
-        <p:txBody>
-          <a:bodyPr wrap="square" lIns="0" tIns="0" rIns="0" bIns="0" rtlCol="0" anchor="t"/>
-          <a:lstStyle/>
-          <a:p>
-            <a:pPr indent="0" marL="0">
-              <a:lnSpc>
-                <a:spcPts val="2000"/>
-              </a:lnSpc>
-              <a:buNone/>
-            </a:pPr>
-            <a:r>
-              <a:rPr lang="en-US" sz="1500" b="1" dirty="0">
-                <a:solidFill>
-                  <a:srgbClr val="1B2430"/>
-                </a:solidFill>
-                <a:latin typeface="Cambria" pitchFamily="34" charset="0"/>
-                <a:ea typeface="Cambria" pitchFamily="34" charset="-122"/>
-                <a:cs typeface="Cambria" pitchFamily="34" charset="-120"/>
-              </a:rPr>
-              <a:t>Start with the biggest spend</a:t>
-            </a:r>
-            <a:endParaRPr lang="en-US" sz="1500" dirty="0"/>
-          </a:p>
-        </p:txBody>
-      </p:sp>
-      <p:sp>
-        <p:nvSpPr>
-          <p:cNvPr id="11" name="Text 9"/>
-          <p:cNvSpPr/>
-          <p:nvPr/>
-        </p:nvSpPr>
-        <p:spPr>
-          <a:xfrm>
-            <a:off x="3621024" y="3346704"/>
-            <a:ext cx="2139696" cy="749808"/>
-          </a:xfrm>
-          <a:prstGeom prst="rect">
-            <a:avLst/>
-          </a:prstGeom>
-          <a:noFill/>
-          <a:ln/>
-        </p:spPr>
-        <p:txBody>
-          <a:bodyPr wrap="square" lIns="0" tIns="0" rIns="0" bIns="0" rtlCol="0" anchor="t"/>
-          <a:lstStyle/>
-          <a:p>
-            <a:pPr indent="0" marL="0">
-              <a:lnSpc>
-                <a:spcPts val="1500"/>
-              </a:lnSpc>
-              <a:buNone/>
-            </a:pPr>
-            <a:r>
-              <a:rPr lang="en-US" sz="1200" dirty="0">
-                <a:solidFill>
-                  <a:srgbClr val="5C6675"/>
-                </a:solidFill>
-                <a:latin typeface="Calibri" pitchFamily="34" charset="0"/>
-                <a:ea typeface="Calibri" pitchFamily="34" charset="-122"/>
-                <a:cs typeface="Calibri" pitchFamily="34" charset="-120"/>
-              </a:rPr>
-              <a:t>Attack the largest categories first. Don't chase perfect granularity everywhere.</a:t>
-            </a:r>
-            <a:endParaRPr lang="en-US" sz="1200" dirty="0"/>
-          </a:p>
-        </p:txBody>
-      </p:sp>
-      <p:sp>
-        <p:nvSpPr>
-          <p:cNvPr id="12" name="Shape 10"/>
-          <p:cNvSpPr/>
-          <p:nvPr/>
-        </p:nvSpPr>
-        <p:spPr>
-          <a:xfrm>
-            <a:off x="6217920" y="1783080"/>
-            <a:ext cx="2587752" cy="2423160"/>
-          </a:xfrm>
-          <a:prstGeom prst="roundRect">
-            <a:avLst>
-              <a:gd name="adj" fmla="val 3396"/>
-            </a:avLst>
-          </a:prstGeom>
-          <a:solidFill>
-            <a:srgbClr val="F1F3F6"/>
-          </a:solidFill>
-          <a:ln/>
-        </p:spPr>
-      </p:sp>
-      <p:sp>
-        <p:nvSpPr>
-          <p:cNvPr id="13" name="Text 11"/>
-          <p:cNvSpPr/>
-          <p:nvPr/>
-        </p:nvSpPr>
-        <p:spPr>
-          <a:xfrm>
-            <a:off x="6473952" y="1965960"/>
-            <a:ext cx="1097280" cy="502920"/>
-          </a:xfrm>
-          <a:prstGeom prst="rect">
-            <a:avLst/>
-          </a:prstGeom>
-          <a:noFill/>
-          <a:ln/>
-        </p:spPr>
-        <p:txBody>
-          <a:bodyPr wrap="square" lIns="0" tIns="0" rIns="0" bIns="0" rtlCol="0" anchor="ctr"/>
-          <a:lstStyle/>
-          <a:p>
-            <a:pPr indent="0" marL="0">
-              <a:buNone/>
-            </a:pPr>
-            <a:r>
-              <a:rPr lang="en-US" sz="2800" b="1" dirty="0">
-                <a:solidFill>
-                  <a:srgbClr val="B9C2CD"/>
-                </a:solidFill>
-                <a:latin typeface="Cambria" pitchFamily="34" charset="0"/>
-                <a:ea typeface="Cambria" pitchFamily="34" charset="-122"/>
-                <a:cs typeface="Cambria" pitchFamily="34" charset="-120"/>
-              </a:rPr>
-              <a:t>03</a:t>
-            </a:r>
-            <a:endParaRPr lang="en-US" sz="2800" dirty="0"/>
-          </a:p>
-        </p:txBody>
-      </p:sp>
-      <p:sp>
-        <p:nvSpPr>
-          <p:cNvPr id="14" name="Text 12"/>
-          <p:cNvSpPr/>
-          <p:nvPr/>
-        </p:nvSpPr>
-        <p:spPr>
-          <a:xfrm>
-            <a:off x="6455664" y="2523744"/>
-            <a:ext cx="2139696" cy="786384"/>
-          </a:xfrm>
-          <a:prstGeom prst="rect">
-            <a:avLst/>
-          </a:prstGeom>
-          <a:noFill/>
-          <a:ln/>
-        </p:spPr>
-        <p:txBody>
-          <a:bodyPr wrap="square" lIns="0" tIns="0" rIns="0" bIns="0" rtlCol="0" anchor="t"/>
-          <a:lstStyle/>
-          <a:p>
-            <a:pPr indent="0" marL="0">
-              <a:lnSpc>
-                <a:spcPts val="2000"/>
-              </a:lnSpc>
-              <a:buNone/>
-            </a:pPr>
-            <a:r>
-              <a:rPr lang="en-US" sz="1500" b="1" dirty="0">
-                <a:solidFill>
-                  <a:srgbClr val="1B2430"/>
-                </a:solidFill>
-                <a:latin typeface="Cambria" pitchFamily="34" charset="0"/>
-                <a:ea typeface="Cambria" pitchFamily="34" charset="-122"/>
-                <a:cs typeface="Cambria" pitchFamily="34" charset="-120"/>
-              </a:rPr>
-              <a:t>Get finance and engineering talking</a:t>
-            </a:r>
-            <a:endParaRPr lang="en-US" sz="1500" dirty="0"/>
-          </a:p>
-        </p:txBody>
-      </p:sp>
-      <p:sp>
-        <p:nvSpPr>
-          <p:cNvPr id="15" name="Text 13"/>
-          <p:cNvSpPr/>
-          <p:nvPr/>
-        </p:nvSpPr>
-        <p:spPr>
-          <a:xfrm>
-            <a:off x="6455664" y="3346704"/>
-            <a:ext cx="2139696" cy="749808"/>
-          </a:xfrm>
-          <a:prstGeom prst="rect">
-            <a:avLst/>
-          </a:prstGeom>
-          <a:noFill/>
-          <a:ln/>
-        </p:spPr>
-        <p:txBody>
-          <a:bodyPr wrap="square" lIns="0" tIns="0" rIns="0" bIns="0" rtlCol="0" anchor="t"/>
-          <a:lstStyle/>
-          <a:p>
-            <a:pPr indent="0" marL="0">
-              <a:lnSpc>
-                <a:spcPts val="1500"/>
-              </a:lnSpc>
-              <a:buNone/>
-            </a:pPr>
-            <a:r>
-              <a:rPr lang="en-US" sz="1200" dirty="0">
-                <a:solidFill>
-                  <a:srgbClr val="5C6675"/>
-                </a:solidFill>
-                <a:latin typeface="Calibri" pitchFamily="34" charset="0"/>
-                <a:ea typeface="Calibri" pitchFamily="34" charset="-122"/>
-                <a:cs typeface="Calibri" pitchFamily="34" charset="-120"/>
-              </a:rPr>
-              <a:t>Bring both into the conversation early, not as an afterthought.</a:t>
-            </a:r>
-            <a:endParaRPr lang="en-US" sz="1200" dirty="0"/>
-          </a:p>
-        </p:txBody>
-      </p:sp>
-      <p:sp>
-        <p:nvSpPr>
-          <p:cNvPr id="16" name="Shape 14"/>
-          <p:cNvSpPr/>
-          <p:nvPr/>
-        </p:nvSpPr>
-        <p:spPr>
-          <a:xfrm>
-            <a:off x="9052560" y="1783080"/>
-            <a:ext cx="2587752" cy="2423160"/>
-          </a:xfrm>
-          <a:prstGeom prst="roundRect">
-            <a:avLst>
-              <a:gd name="adj" fmla="val 3396"/>
-            </a:avLst>
-          </a:prstGeom>
-          <a:solidFill>
-            <a:srgbClr val="F1F3F6"/>
-          </a:solidFill>
-          <a:ln/>
-        </p:spPr>
-      </p:sp>
-      <p:sp>
-        <p:nvSpPr>
-          <p:cNvPr id="17" name="Text 15"/>
-          <p:cNvSpPr/>
-          <p:nvPr/>
-        </p:nvSpPr>
-        <p:spPr>
-          <a:xfrm>
-            <a:off x="9308592" y="1965960"/>
-            <a:ext cx="1097280" cy="502920"/>
-          </a:xfrm>
-          <a:prstGeom prst="rect">
-            <a:avLst/>
-          </a:prstGeom>
-          <a:noFill/>
-          <a:ln/>
-        </p:spPr>
-        <p:txBody>
-          <a:bodyPr wrap="square" lIns="0" tIns="0" rIns="0" bIns="0" rtlCol="0" anchor="ctr"/>
-          <a:lstStyle/>
-          <a:p>
-            <a:pPr indent="0" marL="0">
-              <a:buNone/>
-            </a:pPr>
-            <a:r>
-              <a:rPr lang="en-US" sz="2800" b="1" dirty="0">
-                <a:solidFill>
-                  <a:srgbClr val="B9C2CD"/>
-                </a:solidFill>
-                <a:latin typeface="Cambria" pitchFamily="34" charset="0"/>
-                <a:ea typeface="Cambria" pitchFamily="34" charset="-122"/>
-                <a:cs typeface="Cambria" pitchFamily="34" charset="-120"/>
-              </a:rPr>
-              <a:t>04</a:t>
-            </a:r>
-            <a:endParaRPr lang="en-US" sz="2800" dirty="0"/>
-          </a:p>
-        </p:txBody>
-      </p:sp>
-      <p:sp>
-        <p:nvSpPr>
-          <p:cNvPr id="18" name="Text 16"/>
-          <p:cNvSpPr/>
-          <p:nvPr/>
-        </p:nvSpPr>
-        <p:spPr>
-          <a:xfrm>
-            <a:off x="9290304" y="2523744"/>
-            <a:ext cx="2139696" cy="786384"/>
-          </a:xfrm>
-          <a:prstGeom prst="rect">
-            <a:avLst/>
-          </a:prstGeom>
-          <a:noFill/>
-          <a:ln/>
-        </p:spPr>
-        <p:txBody>
-          <a:bodyPr wrap="square" lIns="0" tIns="0" rIns="0" bIns="0" rtlCol="0" anchor="t"/>
-          <a:lstStyle/>
-          <a:p>
-            <a:pPr indent="0" marL="0">
-              <a:lnSpc>
-                <a:spcPts val="2000"/>
-              </a:lnSpc>
-              <a:buNone/>
-            </a:pPr>
-            <a:r>
-              <a:rPr lang="en-US" sz="1500" b="1" dirty="0">
-                <a:solidFill>
-                  <a:srgbClr val="1B2430"/>
-                </a:solidFill>
-                <a:latin typeface="Cambria" pitchFamily="34" charset="0"/>
-                <a:ea typeface="Cambria" pitchFamily="34" charset="-122"/>
-                <a:cs typeface="Cambria" pitchFamily="34" charset="-120"/>
-              </a:rPr>
-              <a:t>Set guardrails early</a:t>
-            </a:r>
-            <a:endParaRPr lang="en-US" sz="1500" dirty="0"/>
-          </a:p>
-        </p:txBody>
-      </p:sp>
-      <p:sp>
-        <p:nvSpPr>
-          <p:cNvPr id="19" name="Text 17"/>
-          <p:cNvSpPr/>
-          <p:nvPr/>
-        </p:nvSpPr>
-        <p:spPr>
-          <a:xfrm>
-            <a:off x="9290304" y="3346704"/>
-            <a:ext cx="2139696" cy="749808"/>
-          </a:xfrm>
-          <a:prstGeom prst="rect">
-            <a:avLst/>
-          </a:prstGeom>
-          <a:noFill/>
-          <a:ln/>
-        </p:spPr>
-        <p:txBody>
-          <a:bodyPr wrap="square" lIns="0" tIns="0" rIns="0" bIns="0" rtlCol="0" anchor="t"/>
-          <a:lstStyle/>
-          <a:p>
-            <a:pPr indent="0" marL="0">
-              <a:lnSpc>
-                <a:spcPts val="1500"/>
-              </a:lnSpc>
-              <a:buNone/>
-            </a:pPr>
-            <a:r>
-              <a:rPr lang="en-US" sz="1200" dirty="0">
-                <a:solidFill>
-                  <a:srgbClr val="5C6675"/>
-                </a:solidFill>
-                <a:latin typeface="Calibri" pitchFamily="34" charset="0"/>
-                <a:ea typeface="Calibri" pitchFamily="34" charset="-122"/>
-                <a:cs typeface="Calibri" pitchFamily="34" charset="-120"/>
-              </a:rPr>
-              <a:t>Owners, budget thresholds and quotas cost little to add — and stop the expensive surprises.</a:t>
-            </a:r>
-            <a:endParaRPr lang="en-US" sz="1200" dirty="0"/>
-          </a:p>
-        </p:txBody>
-      </p:sp>
-      <p:sp>
-        <p:nvSpPr>
-          <p:cNvPr id="20" name="Shape 18"/>
-          <p:cNvSpPr/>
-          <p:nvPr/>
-        </p:nvSpPr>
-        <p:spPr>
-          <a:xfrm>
-            <a:off x="548640" y="4434840"/>
-            <a:ext cx="11091672" cy="1874520"/>
-          </a:xfrm>
-          <a:prstGeom prst="roundRect">
-            <a:avLst>
-              <a:gd name="adj" fmla="val 4390"/>
-            </a:avLst>
-          </a:prstGeom>
-          <a:solidFill>
-            <a:srgbClr val="F1F3F6"/>
-          </a:solidFill>
-          <a:ln/>
-        </p:spPr>
-      </p:sp>
-      <p:sp>
-        <p:nvSpPr>
-          <p:cNvPr id="21" name="Text 19"/>
-          <p:cNvSpPr/>
-          <p:nvPr/>
-        </p:nvSpPr>
-        <p:spPr>
-          <a:xfrm>
-            <a:off x="877824" y="4572000"/>
-            <a:ext cx="6035040" cy="292608"/>
-          </a:xfrm>
-          <a:prstGeom prst="rect">
-            <a:avLst/>
-          </a:prstGeom>
-          <a:noFill/>
-          <a:ln/>
-        </p:spPr>
-        <p:txBody>
-          <a:bodyPr wrap="square" lIns="0" tIns="0" rIns="0" bIns="0" rtlCol="0" anchor="ctr"/>
-          <a:lstStyle/>
-          <a:p>
-            <a:pPr indent="0" marL="0">
-              <a:buNone/>
-            </a:pPr>
-            <a:r>
-              <a:rPr lang="en-US" sz="1200" b="1" spc="180" kern="0" dirty="0">
-                <a:solidFill>
-                  <a:srgbClr val="5C6675"/>
-                </a:solidFill>
-                <a:latin typeface="Calibri" pitchFamily="34" charset="0"/>
-                <a:ea typeface="Calibri" pitchFamily="34" charset="-122"/>
-                <a:cs typeface="Calibri" pitchFamily="34" charset="-120"/>
-              </a:rPr>
-              <a:t>Tooling — match the footprint, not the ambition</a:t>
-            </a:r>
-            <a:endParaRPr lang="en-US" sz="1200" dirty="0"/>
-          </a:p>
-        </p:txBody>
-      </p:sp>
-      <p:sp>
-        <p:nvSpPr>
-          <p:cNvPr id="22" name="Text 20"/>
-          <p:cNvSpPr/>
-          <p:nvPr/>
-        </p:nvSpPr>
-        <p:spPr>
-          <a:xfrm>
-            <a:off x="877824" y="4937760"/>
-            <a:ext cx="1737360" cy="384048"/>
-          </a:xfrm>
-          <a:prstGeom prst="rect">
-            <a:avLst/>
-          </a:prstGeom>
-          <a:noFill/>
-          <a:ln/>
-        </p:spPr>
-        <p:txBody>
-          <a:bodyPr wrap="square" lIns="0" tIns="0" rIns="0" bIns="0" rtlCol="0" anchor="ctr"/>
-          <a:lstStyle/>
-          <a:p>
-            <a:pPr indent="0" marL="0">
-              <a:buNone/>
-            </a:pPr>
-            <a:r>
-              <a:rPr lang="en-US" sz="1350" b="1" dirty="0">
-                <a:solidFill>
-                  <a:srgbClr val="2E8B7A"/>
-                </a:solidFill>
-                <a:latin typeface="Calibri" pitchFamily="34" charset="0"/>
-                <a:ea typeface="Calibri" pitchFamily="34" charset="-122"/>
-                <a:cs typeface="Calibri" pitchFamily="34" charset="-120"/>
-              </a:rPr>
-              <a:t>Native</a:t>
-            </a:r>
-            <a:endParaRPr lang="en-US" sz="1350" dirty="0"/>
-          </a:p>
-        </p:txBody>
-      </p:sp>
-      <p:sp>
-        <p:nvSpPr>
-          <p:cNvPr id="23" name="Text 21"/>
-          <p:cNvSpPr/>
-          <p:nvPr/>
-        </p:nvSpPr>
-        <p:spPr>
-          <a:xfrm>
-            <a:off x="2651760" y="4937760"/>
-            <a:ext cx="8595360" cy="384048"/>
-          </a:xfrm>
-          <a:prstGeom prst="rect">
-            <a:avLst/>
-          </a:prstGeom>
-          <a:noFill/>
-          <a:ln/>
-        </p:spPr>
-        <p:txBody>
-          <a:bodyPr wrap="square" lIns="0" tIns="0" rIns="0" bIns="0" rtlCol="0" anchor="ctr"/>
-          <a:lstStyle/>
-          <a:p>
-            <a:pPr indent="0" marL="0">
-              <a:buNone/>
-            </a:pPr>
-            <a:r>
-              <a:rPr lang="en-US" sz="1350" dirty="0">
-                <a:solidFill>
-                  <a:srgbClr val="5C6675"/>
-                </a:solidFill>
-                <a:latin typeface="Calibri" pitchFamily="34" charset="0"/>
-                <a:ea typeface="Calibri" pitchFamily="34" charset="-122"/>
-                <a:cs typeface="Calibri" pitchFamily="34" charset="-120"/>
-              </a:rPr>
-              <a:t>AWS Cost Explorer  ·  Azure Cost Management  ·  GCP Billing</a:t>
-            </a:r>
-            <a:endParaRPr lang="en-US" sz="1350" dirty="0"/>
-          </a:p>
-        </p:txBody>
-      </p:sp>
-      <p:sp>
-        <p:nvSpPr>
-          <p:cNvPr id="24" name="Text 22"/>
-          <p:cNvSpPr/>
-          <p:nvPr/>
-        </p:nvSpPr>
-        <p:spPr>
-          <a:xfrm>
-            <a:off x="877824" y="5349240"/>
-            <a:ext cx="1737360" cy="384048"/>
-          </a:xfrm>
-          <a:prstGeom prst="rect">
-            <a:avLst/>
-          </a:prstGeom>
-          <a:noFill/>
-          <a:ln/>
-        </p:spPr>
-        <p:txBody>
-          <a:bodyPr wrap="square" lIns="0" tIns="0" rIns="0" bIns="0" rtlCol="0" anchor="ctr"/>
-          <a:lstStyle/>
-          <a:p>
-            <a:pPr indent="0" marL="0">
-              <a:buNone/>
-            </a:pPr>
-            <a:r>
-              <a:rPr lang="en-US" sz="1350" b="1" dirty="0">
-                <a:solidFill>
-                  <a:srgbClr val="B87B18"/>
-                </a:solidFill>
-                <a:latin typeface="Calibri" pitchFamily="34" charset="0"/>
-                <a:ea typeface="Calibri" pitchFamily="34" charset="-122"/>
-                <a:cs typeface="Calibri" pitchFamily="34" charset="-120"/>
-              </a:rPr>
-              <a:t>Third-party</a:t>
-            </a:r>
-            <a:endParaRPr lang="en-US" sz="1350" dirty="0"/>
-          </a:p>
-        </p:txBody>
-      </p:sp>
-      <p:sp>
-        <p:nvSpPr>
-          <p:cNvPr id="25" name="Text 23"/>
-          <p:cNvSpPr/>
-          <p:nvPr/>
-        </p:nvSpPr>
-        <p:spPr>
-          <a:xfrm>
-            <a:off x="2651760" y="5349240"/>
-            <a:ext cx="8595360" cy="384048"/>
-          </a:xfrm>
-          <a:prstGeom prst="rect">
-            <a:avLst/>
-          </a:prstGeom>
-          <a:noFill/>
-          <a:ln/>
-        </p:spPr>
-        <p:txBody>
-          <a:bodyPr wrap="square" lIns="0" tIns="0" rIns="0" bIns="0" rtlCol="0" anchor="ctr"/>
-          <a:lstStyle/>
-          <a:p>
-            <a:pPr indent="0" marL="0">
-              <a:buNone/>
-            </a:pPr>
-            <a:r>
-              <a:rPr lang="en-US" sz="1350" dirty="0">
-                <a:solidFill>
-                  <a:srgbClr val="5C6675"/>
-                </a:solidFill>
-                <a:latin typeface="Calibri" pitchFamily="34" charset="0"/>
-                <a:ea typeface="Calibri" pitchFamily="34" charset="-122"/>
-                <a:cs typeface="Calibri" pitchFamily="34" charset="-120"/>
-              </a:rPr>
-              <a:t>CloudHealth  ·  Apptio  ·  Vantage  ·  nOps  ·  Finout  ·  CoreStack</a:t>
-            </a:r>
-            <a:endParaRPr lang="en-US" sz="1350" dirty="0"/>
-          </a:p>
-        </p:txBody>
-      </p:sp>
-      <p:sp>
-        <p:nvSpPr>
-          <p:cNvPr id="26" name="Text 24"/>
-          <p:cNvSpPr/>
-          <p:nvPr/>
-        </p:nvSpPr>
-        <p:spPr>
-          <a:xfrm>
-            <a:off x="877824" y="5760720"/>
-            <a:ext cx="1737360" cy="384048"/>
-          </a:xfrm>
-          <a:prstGeom prst="rect">
-            <a:avLst/>
-          </a:prstGeom>
-          <a:noFill/>
-          <a:ln/>
-        </p:spPr>
-        <p:txBody>
-          <a:bodyPr wrap="square" lIns="0" tIns="0" rIns="0" bIns="0" rtlCol="0" anchor="ctr"/>
-          <a:lstStyle/>
-          <a:p>
-            <a:pPr indent="0" marL="0">
-              <a:buNone/>
-            </a:pPr>
-            <a:r>
-              <a:rPr lang="en-US" sz="1350" b="1" dirty="0">
-                <a:solidFill>
-                  <a:srgbClr val="1B2430"/>
-                </a:solidFill>
-                <a:latin typeface="Calibri" pitchFamily="34" charset="0"/>
-                <a:ea typeface="Calibri" pitchFamily="34" charset="-122"/>
-                <a:cs typeface="Calibri" pitchFamily="34" charset="-120"/>
-              </a:rPr>
-              <a:t>Standard</a:t>
-            </a:r>
-            <a:endParaRPr lang="en-US" sz="1350" dirty="0"/>
-          </a:p>
-        </p:txBody>
-      </p:sp>
-      <p:sp>
-        <p:nvSpPr>
-          <p:cNvPr id="27" name="Text 25"/>
-          <p:cNvSpPr/>
-          <p:nvPr/>
-        </p:nvSpPr>
-        <p:spPr>
-          <a:xfrm>
-            <a:off x="2651760" y="5760720"/>
-            <a:ext cx="8595360" cy="384048"/>
-          </a:xfrm>
-          <a:prstGeom prst="rect">
-            <a:avLst/>
-          </a:prstGeom>
-          <a:noFill/>
-          <a:ln/>
-        </p:spPr>
-        <p:txBody>
-          <a:bodyPr wrap="square" lIns="0" tIns="0" rIns="0" bIns="0" rtlCol="0" anchor="ctr"/>
-          <a:lstStyle/>
-          <a:p>
-            <a:pPr indent="0" marL="0">
-              <a:buNone/>
-            </a:pPr>
-            <a:r>
-              <a:rPr lang="en-US" sz="1350" dirty="0">
-                <a:solidFill>
-                  <a:srgbClr val="5C6675"/>
-                </a:solidFill>
-                <a:latin typeface="Calibri" pitchFamily="34" charset="0"/>
-                <a:ea typeface="Calibri" pitchFamily="34" charset="-122"/>
-                <a:cs typeface="Calibri" pitchFamily="34" charset="-120"/>
-              </a:rPr>
-              <a:t>FOCUS-compliant platforms for multi-cloud reporting</a:t>
-            </a:r>
-            <a:endParaRPr lang="en-US" sz="1350" dirty="0"/>
+              <a:t>The goal is not a smaller invoice. It is an invoice with nothing in it you have not already seen, explained and decided about.</a:t>
+            </a:r>
+            <a:endParaRPr lang="en-US" sz="1550" dirty="0"/>
           </a:p>
         </p:txBody>
       </p:sp>
@@ -13787,6 +14145,991 @@
     <p:bg>
       <p:bgPr>
         <a:solidFill>
+          <a:srgbClr val="FFFFFF"/>
+        </a:solidFill>
+      </p:bgPr>
+    </p:bg>
+    <p:spTree>
+      <p:nvGrpSpPr>
+        <p:cNvPr id="1" name=""/>
+        <p:cNvGrpSpPr/>
+        <p:nvPr/>
+      </p:nvGrpSpPr>
+      <p:grpSpPr>
+        <a:xfrm>
+          <a:off x="0" y="0"/>
+          <a:ext cx="0" cy="0"/>
+          <a:chOff x="0" y="0"/>
+          <a:chExt cx="0" cy="0"/>
+        </a:xfrm>
+      </p:grpSpPr>
+      <p:sp>
+        <p:nvSpPr>
+          <p:cNvPr id="2" name="Text 0"/>
+          <p:cNvSpPr/>
+          <p:nvPr/>
+        </p:nvSpPr>
+        <p:spPr>
+          <a:xfrm>
+            <a:off x="548640" y="475488"/>
+            <a:ext cx="7315200" cy="256032"/>
+          </a:xfrm>
+          <a:prstGeom prst="rect">
+            <a:avLst/>
+          </a:prstGeom>
+          <a:noFill/>
+          <a:ln/>
+        </p:spPr>
+        <p:txBody>
+          <a:bodyPr wrap="square" lIns="0" tIns="0" rIns="0" bIns="0" rtlCol="0" anchor="ctr"/>
+          <a:lstStyle/>
+          <a:p>
+            <a:pPr indent="0" marL="0">
+              <a:buNone/>
+            </a:pPr>
+            <a:r>
+              <a:rPr lang="en-US" sz="1100" b="1" spc="220" kern="0" dirty="0">
+                <a:solidFill>
+                  <a:srgbClr val="E39B2C"/>
+                </a:solidFill>
+                <a:latin typeface="Calibri" pitchFamily="34" charset="0"/>
+                <a:ea typeface="Calibri" pitchFamily="34" charset="-122"/>
+                <a:cs typeface="Calibri" pitchFamily="34" charset="-120"/>
+              </a:rPr>
+              <a:t>THE PATH FORWARD</a:t>
+            </a:r>
+            <a:endParaRPr lang="en-US" sz="1100" dirty="0"/>
+          </a:p>
+        </p:txBody>
+      </p:sp>
+      <p:sp>
+        <p:nvSpPr>
+          <p:cNvPr id="3" name="Text 1"/>
+          <p:cNvSpPr/>
+          <p:nvPr/>
+        </p:nvSpPr>
+        <p:spPr>
+          <a:xfrm>
+            <a:off x="548640" y="768096"/>
+            <a:ext cx="11091672" cy="804672"/>
+          </a:xfrm>
+          <a:prstGeom prst="rect">
+            <a:avLst/>
+          </a:prstGeom>
+          <a:noFill/>
+          <a:ln/>
+        </p:spPr>
+        <p:txBody>
+          <a:bodyPr wrap="square" lIns="0" tIns="0" rIns="0" bIns="0" rtlCol="0" anchor="ctr"/>
+          <a:lstStyle/>
+          <a:p>
+            <a:pPr indent="0" marL="0">
+              <a:buNone/>
+            </a:pPr>
+            <a:r>
+              <a:rPr lang="en-US" sz="3100" b="1" dirty="0">
+                <a:solidFill>
+                  <a:srgbClr val="1B2430"/>
+                </a:solidFill>
+                <a:latin typeface="Cambria" pitchFamily="34" charset="0"/>
+                <a:ea typeface="Cambria" pitchFamily="34" charset="-122"/>
+                <a:cs typeface="Cambria" pitchFamily="34" charset="-120"/>
+              </a:rPr>
+              <a:t>Where to start</a:t>
+            </a:r>
+            <a:endParaRPr lang="en-US" sz="3100" dirty="0"/>
+          </a:p>
+        </p:txBody>
+      </p:sp>
+      <p:sp>
+        <p:nvSpPr>
+          <p:cNvPr id="4" name="Shape 2"/>
+          <p:cNvSpPr/>
+          <p:nvPr/>
+        </p:nvSpPr>
+        <p:spPr>
+          <a:xfrm>
+            <a:off x="548640" y="1783080"/>
+            <a:ext cx="2587752" cy="2423160"/>
+          </a:xfrm>
+          <a:prstGeom prst="roundRect">
+            <a:avLst>
+              <a:gd name="adj" fmla="val 3396"/>
+            </a:avLst>
+          </a:prstGeom>
+          <a:solidFill>
+            <a:srgbClr val="1F2936"/>
+          </a:solidFill>
+          <a:ln/>
+        </p:spPr>
+      </p:sp>
+      <p:sp>
+        <p:nvSpPr>
+          <p:cNvPr id="5" name="Text 3"/>
+          <p:cNvSpPr/>
+          <p:nvPr/>
+        </p:nvSpPr>
+        <p:spPr>
+          <a:xfrm>
+            <a:off x="804672" y="1965960"/>
+            <a:ext cx="1097280" cy="502920"/>
+          </a:xfrm>
+          <a:prstGeom prst="rect">
+            <a:avLst/>
+          </a:prstGeom>
+          <a:noFill/>
+          <a:ln/>
+        </p:spPr>
+        <p:txBody>
+          <a:bodyPr wrap="square" lIns="0" tIns="0" rIns="0" bIns="0" rtlCol="0" anchor="ctr"/>
+          <a:lstStyle/>
+          <a:p>
+            <a:pPr indent="0" marL="0">
+              <a:buNone/>
+            </a:pPr>
+            <a:r>
+              <a:rPr lang="en-US" sz="2800" b="1" dirty="0">
+                <a:solidFill>
+                  <a:srgbClr val="E39B2C"/>
+                </a:solidFill>
+                <a:latin typeface="Cambria" pitchFamily="34" charset="0"/>
+                <a:ea typeface="Cambria" pitchFamily="34" charset="-122"/>
+                <a:cs typeface="Cambria" pitchFamily="34" charset="-120"/>
+              </a:rPr>
+              <a:t>01</a:t>
+            </a:r>
+            <a:endParaRPr lang="en-US" sz="2800" dirty="0"/>
+          </a:p>
+        </p:txBody>
+      </p:sp>
+      <p:sp>
+        <p:nvSpPr>
+          <p:cNvPr id="6" name="Text 4"/>
+          <p:cNvSpPr/>
+          <p:nvPr/>
+        </p:nvSpPr>
+        <p:spPr>
+          <a:xfrm>
+            <a:off x="786384" y="2523744"/>
+            <a:ext cx="2139696" cy="786384"/>
+          </a:xfrm>
+          <a:prstGeom prst="rect">
+            <a:avLst/>
+          </a:prstGeom>
+          <a:noFill/>
+          <a:ln/>
+        </p:spPr>
+        <p:txBody>
+          <a:bodyPr wrap="square" lIns="0" tIns="0" rIns="0" bIns="0" rtlCol="0" anchor="t"/>
+          <a:lstStyle/>
+          <a:p>
+            <a:pPr indent="0" marL="0">
+              <a:lnSpc>
+                <a:spcPts val="2000"/>
+              </a:lnSpc>
+              <a:buNone/>
+            </a:pPr>
+            <a:r>
+              <a:rPr lang="en-US" sz="1500" b="1" dirty="0">
+                <a:solidFill>
+                  <a:srgbClr val="FFFFFF"/>
+                </a:solidFill>
+                <a:latin typeface="Cambria" pitchFamily="34" charset="0"/>
+                <a:ea typeface="Cambria" pitchFamily="34" charset="-122"/>
+                <a:cs typeface="Cambria" pitchFamily="34" charset="-120"/>
+              </a:rPr>
+              <a:t>Set the tagging standard</a:t>
+            </a:r>
+            <a:endParaRPr lang="en-US" sz="1500" dirty="0"/>
+          </a:p>
+        </p:txBody>
+      </p:sp>
+      <p:sp>
+        <p:nvSpPr>
+          <p:cNvPr id="7" name="Text 5"/>
+          <p:cNvSpPr/>
+          <p:nvPr/>
+        </p:nvSpPr>
+        <p:spPr>
+          <a:xfrm>
+            <a:off x="786384" y="3346704"/>
+            <a:ext cx="2139696" cy="749808"/>
+          </a:xfrm>
+          <a:prstGeom prst="rect">
+            <a:avLst/>
+          </a:prstGeom>
+          <a:noFill/>
+          <a:ln/>
+        </p:spPr>
+        <p:txBody>
+          <a:bodyPr wrap="square" lIns="0" tIns="0" rIns="0" bIns="0" rtlCol="0" anchor="t"/>
+          <a:lstStyle/>
+          <a:p>
+            <a:pPr indent="0" marL="0">
+              <a:lnSpc>
+                <a:spcPts val="1500"/>
+              </a:lnSpc>
+              <a:buNone/>
+            </a:pPr>
+            <a:r>
+              <a:rPr lang="en-US" sz="1200" dirty="0">
+                <a:solidFill>
+                  <a:srgbClr val="9EABBA"/>
+                </a:solidFill>
+                <a:latin typeface="Calibri" pitchFamily="34" charset="0"/>
+                <a:ea typeface="Calibri" pitchFamily="34" charset="-122"/>
+                <a:cs typeface="Calibri" pitchFamily="34" charset="-120"/>
+              </a:rPr>
+              <a:t>Agree a consistent taxonomy before investing in dashboards.</a:t>
+            </a:r>
+            <a:endParaRPr lang="en-US" sz="1200" dirty="0"/>
+          </a:p>
+        </p:txBody>
+      </p:sp>
+      <p:sp>
+        <p:nvSpPr>
+          <p:cNvPr id="8" name="Shape 6"/>
+          <p:cNvSpPr/>
+          <p:nvPr/>
+        </p:nvSpPr>
+        <p:spPr>
+          <a:xfrm>
+            <a:off x="3383280" y="1783080"/>
+            <a:ext cx="2587752" cy="2423160"/>
+          </a:xfrm>
+          <a:prstGeom prst="roundRect">
+            <a:avLst>
+              <a:gd name="adj" fmla="val 3396"/>
+            </a:avLst>
+          </a:prstGeom>
+          <a:solidFill>
+            <a:srgbClr val="F1F3F6"/>
+          </a:solidFill>
+          <a:ln/>
+        </p:spPr>
+      </p:sp>
+      <p:sp>
+        <p:nvSpPr>
+          <p:cNvPr id="9" name="Text 7"/>
+          <p:cNvSpPr/>
+          <p:nvPr/>
+        </p:nvSpPr>
+        <p:spPr>
+          <a:xfrm>
+            <a:off x="3639312" y="1965960"/>
+            <a:ext cx="1097280" cy="502920"/>
+          </a:xfrm>
+          <a:prstGeom prst="rect">
+            <a:avLst/>
+          </a:prstGeom>
+          <a:noFill/>
+          <a:ln/>
+        </p:spPr>
+        <p:txBody>
+          <a:bodyPr wrap="square" lIns="0" tIns="0" rIns="0" bIns="0" rtlCol="0" anchor="ctr"/>
+          <a:lstStyle/>
+          <a:p>
+            <a:pPr indent="0" marL="0">
+              <a:buNone/>
+            </a:pPr>
+            <a:r>
+              <a:rPr lang="en-US" sz="2800" b="1" dirty="0">
+                <a:solidFill>
+                  <a:srgbClr val="B9C2CD"/>
+                </a:solidFill>
+                <a:latin typeface="Cambria" pitchFamily="34" charset="0"/>
+                <a:ea typeface="Cambria" pitchFamily="34" charset="-122"/>
+                <a:cs typeface="Cambria" pitchFamily="34" charset="-120"/>
+              </a:rPr>
+              <a:t>02</a:t>
+            </a:r>
+            <a:endParaRPr lang="en-US" sz="2800" dirty="0"/>
+          </a:p>
+        </p:txBody>
+      </p:sp>
+      <p:sp>
+        <p:nvSpPr>
+          <p:cNvPr id="10" name="Text 8"/>
+          <p:cNvSpPr/>
+          <p:nvPr/>
+        </p:nvSpPr>
+        <p:spPr>
+          <a:xfrm>
+            <a:off x="3621024" y="2523744"/>
+            <a:ext cx="2139696" cy="786384"/>
+          </a:xfrm>
+          <a:prstGeom prst="rect">
+            <a:avLst/>
+          </a:prstGeom>
+          <a:noFill/>
+          <a:ln/>
+        </p:spPr>
+        <p:txBody>
+          <a:bodyPr wrap="square" lIns="0" tIns="0" rIns="0" bIns="0" rtlCol="0" anchor="t"/>
+          <a:lstStyle/>
+          <a:p>
+            <a:pPr indent="0" marL="0">
+              <a:lnSpc>
+                <a:spcPts val="2000"/>
+              </a:lnSpc>
+              <a:buNone/>
+            </a:pPr>
+            <a:r>
+              <a:rPr lang="en-US" sz="1500" b="1" dirty="0">
+                <a:solidFill>
+                  <a:srgbClr val="1B2430"/>
+                </a:solidFill>
+                <a:latin typeface="Cambria" pitchFamily="34" charset="0"/>
+                <a:ea typeface="Cambria" pitchFamily="34" charset="-122"/>
+                <a:cs typeface="Cambria" pitchFamily="34" charset="-120"/>
+              </a:rPr>
+              <a:t>Start with the biggest spend</a:t>
+            </a:r>
+            <a:endParaRPr lang="en-US" sz="1500" dirty="0"/>
+          </a:p>
+        </p:txBody>
+      </p:sp>
+      <p:sp>
+        <p:nvSpPr>
+          <p:cNvPr id="11" name="Text 9"/>
+          <p:cNvSpPr/>
+          <p:nvPr/>
+        </p:nvSpPr>
+        <p:spPr>
+          <a:xfrm>
+            <a:off x="3621024" y="3346704"/>
+            <a:ext cx="2139696" cy="749808"/>
+          </a:xfrm>
+          <a:prstGeom prst="rect">
+            <a:avLst/>
+          </a:prstGeom>
+          <a:noFill/>
+          <a:ln/>
+        </p:spPr>
+        <p:txBody>
+          <a:bodyPr wrap="square" lIns="0" tIns="0" rIns="0" bIns="0" rtlCol="0" anchor="t"/>
+          <a:lstStyle/>
+          <a:p>
+            <a:pPr indent="0" marL="0">
+              <a:lnSpc>
+                <a:spcPts val="1500"/>
+              </a:lnSpc>
+              <a:buNone/>
+            </a:pPr>
+            <a:r>
+              <a:rPr lang="en-US" sz="1200" dirty="0">
+                <a:solidFill>
+                  <a:srgbClr val="5C6675"/>
+                </a:solidFill>
+                <a:latin typeface="Calibri" pitchFamily="34" charset="0"/>
+                <a:ea typeface="Calibri" pitchFamily="34" charset="-122"/>
+                <a:cs typeface="Calibri" pitchFamily="34" charset="-120"/>
+              </a:rPr>
+              <a:t>Attack the largest categories first. Don't chase perfect granularity everywhere.</a:t>
+            </a:r>
+            <a:endParaRPr lang="en-US" sz="1200" dirty="0"/>
+          </a:p>
+        </p:txBody>
+      </p:sp>
+      <p:sp>
+        <p:nvSpPr>
+          <p:cNvPr id="12" name="Shape 10"/>
+          <p:cNvSpPr/>
+          <p:nvPr/>
+        </p:nvSpPr>
+        <p:spPr>
+          <a:xfrm>
+            <a:off x="6217920" y="1783080"/>
+            <a:ext cx="2587752" cy="2423160"/>
+          </a:xfrm>
+          <a:prstGeom prst="roundRect">
+            <a:avLst>
+              <a:gd name="adj" fmla="val 3396"/>
+            </a:avLst>
+          </a:prstGeom>
+          <a:solidFill>
+            <a:srgbClr val="F1F3F6"/>
+          </a:solidFill>
+          <a:ln/>
+        </p:spPr>
+      </p:sp>
+      <p:sp>
+        <p:nvSpPr>
+          <p:cNvPr id="13" name="Text 11"/>
+          <p:cNvSpPr/>
+          <p:nvPr/>
+        </p:nvSpPr>
+        <p:spPr>
+          <a:xfrm>
+            <a:off x="6473952" y="1965960"/>
+            <a:ext cx="1097280" cy="502920"/>
+          </a:xfrm>
+          <a:prstGeom prst="rect">
+            <a:avLst/>
+          </a:prstGeom>
+          <a:noFill/>
+          <a:ln/>
+        </p:spPr>
+        <p:txBody>
+          <a:bodyPr wrap="square" lIns="0" tIns="0" rIns="0" bIns="0" rtlCol="0" anchor="ctr"/>
+          <a:lstStyle/>
+          <a:p>
+            <a:pPr indent="0" marL="0">
+              <a:buNone/>
+            </a:pPr>
+            <a:r>
+              <a:rPr lang="en-US" sz="2800" b="1" dirty="0">
+                <a:solidFill>
+                  <a:srgbClr val="B9C2CD"/>
+                </a:solidFill>
+                <a:latin typeface="Cambria" pitchFamily="34" charset="0"/>
+                <a:ea typeface="Cambria" pitchFamily="34" charset="-122"/>
+                <a:cs typeface="Cambria" pitchFamily="34" charset="-120"/>
+              </a:rPr>
+              <a:t>03</a:t>
+            </a:r>
+            <a:endParaRPr lang="en-US" sz="2800" dirty="0"/>
+          </a:p>
+        </p:txBody>
+      </p:sp>
+      <p:sp>
+        <p:nvSpPr>
+          <p:cNvPr id="14" name="Text 12"/>
+          <p:cNvSpPr/>
+          <p:nvPr/>
+        </p:nvSpPr>
+        <p:spPr>
+          <a:xfrm>
+            <a:off x="6455664" y="2523744"/>
+            <a:ext cx="2139696" cy="786384"/>
+          </a:xfrm>
+          <a:prstGeom prst="rect">
+            <a:avLst/>
+          </a:prstGeom>
+          <a:noFill/>
+          <a:ln/>
+        </p:spPr>
+        <p:txBody>
+          <a:bodyPr wrap="square" lIns="0" tIns="0" rIns="0" bIns="0" rtlCol="0" anchor="t"/>
+          <a:lstStyle/>
+          <a:p>
+            <a:pPr indent="0" marL="0">
+              <a:lnSpc>
+                <a:spcPts val="2000"/>
+              </a:lnSpc>
+              <a:buNone/>
+            </a:pPr>
+            <a:r>
+              <a:rPr lang="en-US" sz="1500" b="1" dirty="0">
+                <a:solidFill>
+                  <a:srgbClr val="1B2430"/>
+                </a:solidFill>
+                <a:latin typeface="Cambria" pitchFamily="34" charset="0"/>
+                <a:ea typeface="Cambria" pitchFamily="34" charset="-122"/>
+                <a:cs typeface="Cambria" pitchFamily="34" charset="-120"/>
+              </a:rPr>
+              <a:t>Get finance and engineering talking</a:t>
+            </a:r>
+            <a:endParaRPr lang="en-US" sz="1500" dirty="0"/>
+          </a:p>
+        </p:txBody>
+      </p:sp>
+      <p:sp>
+        <p:nvSpPr>
+          <p:cNvPr id="15" name="Text 13"/>
+          <p:cNvSpPr/>
+          <p:nvPr/>
+        </p:nvSpPr>
+        <p:spPr>
+          <a:xfrm>
+            <a:off x="6455664" y="3346704"/>
+            <a:ext cx="2139696" cy="749808"/>
+          </a:xfrm>
+          <a:prstGeom prst="rect">
+            <a:avLst/>
+          </a:prstGeom>
+          <a:noFill/>
+          <a:ln/>
+        </p:spPr>
+        <p:txBody>
+          <a:bodyPr wrap="square" lIns="0" tIns="0" rIns="0" bIns="0" rtlCol="0" anchor="t"/>
+          <a:lstStyle/>
+          <a:p>
+            <a:pPr indent="0" marL="0">
+              <a:lnSpc>
+                <a:spcPts val="1500"/>
+              </a:lnSpc>
+              <a:buNone/>
+            </a:pPr>
+            <a:r>
+              <a:rPr lang="en-US" sz="1200" dirty="0">
+                <a:solidFill>
+                  <a:srgbClr val="5C6675"/>
+                </a:solidFill>
+                <a:latin typeface="Calibri" pitchFamily="34" charset="0"/>
+                <a:ea typeface="Calibri" pitchFamily="34" charset="-122"/>
+                <a:cs typeface="Calibri" pitchFamily="34" charset="-120"/>
+              </a:rPr>
+              <a:t>Bring both into the conversation early, not as an afterthought.</a:t>
+            </a:r>
+            <a:endParaRPr lang="en-US" sz="1200" dirty="0"/>
+          </a:p>
+        </p:txBody>
+      </p:sp>
+      <p:sp>
+        <p:nvSpPr>
+          <p:cNvPr id="16" name="Shape 14"/>
+          <p:cNvSpPr/>
+          <p:nvPr/>
+        </p:nvSpPr>
+        <p:spPr>
+          <a:xfrm>
+            <a:off x="9052560" y="1783080"/>
+            <a:ext cx="2587752" cy="2423160"/>
+          </a:xfrm>
+          <a:prstGeom prst="roundRect">
+            <a:avLst>
+              <a:gd name="adj" fmla="val 3396"/>
+            </a:avLst>
+          </a:prstGeom>
+          <a:solidFill>
+            <a:srgbClr val="F1F3F6"/>
+          </a:solidFill>
+          <a:ln/>
+        </p:spPr>
+      </p:sp>
+      <p:sp>
+        <p:nvSpPr>
+          <p:cNvPr id="17" name="Text 15"/>
+          <p:cNvSpPr/>
+          <p:nvPr/>
+        </p:nvSpPr>
+        <p:spPr>
+          <a:xfrm>
+            <a:off x="9308592" y="1965960"/>
+            <a:ext cx="1097280" cy="502920"/>
+          </a:xfrm>
+          <a:prstGeom prst="rect">
+            <a:avLst/>
+          </a:prstGeom>
+          <a:noFill/>
+          <a:ln/>
+        </p:spPr>
+        <p:txBody>
+          <a:bodyPr wrap="square" lIns="0" tIns="0" rIns="0" bIns="0" rtlCol="0" anchor="ctr"/>
+          <a:lstStyle/>
+          <a:p>
+            <a:pPr indent="0" marL="0">
+              <a:buNone/>
+            </a:pPr>
+            <a:r>
+              <a:rPr lang="en-US" sz="2800" b="1" dirty="0">
+                <a:solidFill>
+                  <a:srgbClr val="B9C2CD"/>
+                </a:solidFill>
+                <a:latin typeface="Cambria" pitchFamily="34" charset="0"/>
+                <a:ea typeface="Cambria" pitchFamily="34" charset="-122"/>
+                <a:cs typeface="Cambria" pitchFamily="34" charset="-120"/>
+              </a:rPr>
+              <a:t>04</a:t>
+            </a:r>
+            <a:endParaRPr lang="en-US" sz="2800" dirty="0"/>
+          </a:p>
+        </p:txBody>
+      </p:sp>
+      <p:sp>
+        <p:nvSpPr>
+          <p:cNvPr id="18" name="Text 16"/>
+          <p:cNvSpPr/>
+          <p:nvPr/>
+        </p:nvSpPr>
+        <p:spPr>
+          <a:xfrm>
+            <a:off x="9290304" y="2523744"/>
+            <a:ext cx="2139696" cy="786384"/>
+          </a:xfrm>
+          <a:prstGeom prst="rect">
+            <a:avLst/>
+          </a:prstGeom>
+          <a:noFill/>
+          <a:ln/>
+        </p:spPr>
+        <p:txBody>
+          <a:bodyPr wrap="square" lIns="0" tIns="0" rIns="0" bIns="0" rtlCol="0" anchor="t"/>
+          <a:lstStyle/>
+          <a:p>
+            <a:pPr indent="0" marL="0">
+              <a:lnSpc>
+                <a:spcPts val="2000"/>
+              </a:lnSpc>
+              <a:buNone/>
+            </a:pPr>
+            <a:r>
+              <a:rPr lang="en-US" sz="1500" b="1" dirty="0">
+                <a:solidFill>
+                  <a:srgbClr val="1B2430"/>
+                </a:solidFill>
+                <a:latin typeface="Cambria" pitchFamily="34" charset="0"/>
+                <a:ea typeface="Cambria" pitchFamily="34" charset="-122"/>
+                <a:cs typeface="Cambria" pitchFamily="34" charset="-120"/>
+              </a:rPr>
+              <a:t>Set guardrails early</a:t>
+            </a:r>
+            <a:endParaRPr lang="en-US" sz="1500" dirty="0"/>
+          </a:p>
+        </p:txBody>
+      </p:sp>
+      <p:sp>
+        <p:nvSpPr>
+          <p:cNvPr id="19" name="Text 17"/>
+          <p:cNvSpPr/>
+          <p:nvPr/>
+        </p:nvSpPr>
+        <p:spPr>
+          <a:xfrm>
+            <a:off x="9290304" y="3346704"/>
+            <a:ext cx="2139696" cy="749808"/>
+          </a:xfrm>
+          <a:prstGeom prst="rect">
+            <a:avLst/>
+          </a:prstGeom>
+          <a:noFill/>
+          <a:ln/>
+        </p:spPr>
+        <p:txBody>
+          <a:bodyPr wrap="square" lIns="0" tIns="0" rIns="0" bIns="0" rtlCol="0" anchor="t"/>
+          <a:lstStyle/>
+          <a:p>
+            <a:pPr indent="0" marL="0">
+              <a:lnSpc>
+                <a:spcPts val="1500"/>
+              </a:lnSpc>
+              <a:buNone/>
+            </a:pPr>
+            <a:r>
+              <a:rPr lang="en-US" sz="1200" dirty="0">
+                <a:solidFill>
+                  <a:srgbClr val="5C6675"/>
+                </a:solidFill>
+                <a:latin typeface="Calibri" pitchFamily="34" charset="0"/>
+                <a:ea typeface="Calibri" pitchFamily="34" charset="-122"/>
+                <a:cs typeface="Calibri" pitchFamily="34" charset="-120"/>
+              </a:rPr>
+              <a:t>Owners, budget thresholds and quotas cost little to add — and stop the expensive surprises.</a:t>
+            </a:r>
+            <a:endParaRPr lang="en-US" sz="1200" dirty="0"/>
+          </a:p>
+        </p:txBody>
+      </p:sp>
+      <p:sp>
+        <p:nvSpPr>
+          <p:cNvPr id="20" name="Shape 18"/>
+          <p:cNvSpPr/>
+          <p:nvPr/>
+        </p:nvSpPr>
+        <p:spPr>
+          <a:xfrm>
+            <a:off x="548640" y="4434840"/>
+            <a:ext cx="11091672" cy="1874520"/>
+          </a:xfrm>
+          <a:prstGeom prst="roundRect">
+            <a:avLst>
+              <a:gd name="adj" fmla="val 4390"/>
+            </a:avLst>
+          </a:prstGeom>
+          <a:solidFill>
+            <a:srgbClr val="F1F3F6"/>
+          </a:solidFill>
+          <a:ln/>
+        </p:spPr>
+      </p:sp>
+      <p:sp>
+        <p:nvSpPr>
+          <p:cNvPr id="21" name="Text 19"/>
+          <p:cNvSpPr/>
+          <p:nvPr/>
+        </p:nvSpPr>
+        <p:spPr>
+          <a:xfrm>
+            <a:off x="877824" y="4572000"/>
+            <a:ext cx="6035040" cy="292608"/>
+          </a:xfrm>
+          <a:prstGeom prst="rect">
+            <a:avLst/>
+          </a:prstGeom>
+          <a:noFill/>
+          <a:ln/>
+        </p:spPr>
+        <p:txBody>
+          <a:bodyPr wrap="square" lIns="0" tIns="0" rIns="0" bIns="0" rtlCol="0" anchor="ctr"/>
+          <a:lstStyle/>
+          <a:p>
+            <a:pPr indent="0" marL="0">
+              <a:buNone/>
+            </a:pPr>
+            <a:r>
+              <a:rPr lang="en-US" sz="1200" b="1" spc="180" kern="0" dirty="0">
+                <a:solidFill>
+                  <a:srgbClr val="5C6675"/>
+                </a:solidFill>
+                <a:latin typeface="Calibri" pitchFamily="34" charset="0"/>
+                <a:ea typeface="Calibri" pitchFamily="34" charset="-122"/>
+                <a:cs typeface="Calibri" pitchFamily="34" charset="-120"/>
+              </a:rPr>
+              <a:t>Tooling — match the footprint, not the ambition</a:t>
+            </a:r>
+            <a:endParaRPr lang="en-US" sz="1200" dirty="0"/>
+          </a:p>
+        </p:txBody>
+      </p:sp>
+      <p:sp>
+        <p:nvSpPr>
+          <p:cNvPr id="22" name="Text 20"/>
+          <p:cNvSpPr/>
+          <p:nvPr/>
+        </p:nvSpPr>
+        <p:spPr>
+          <a:xfrm>
+            <a:off x="877824" y="4937760"/>
+            <a:ext cx="1737360" cy="384048"/>
+          </a:xfrm>
+          <a:prstGeom prst="rect">
+            <a:avLst/>
+          </a:prstGeom>
+          <a:noFill/>
+          <a:ln/>
+        </p:spPr>
+        <p:txBody>
+          <a:bodyPr wrap="square" lIns="0" tIns="0" rIns="0" bIns="0" rtlCol="0" anchor="ctr"/>
+          <a:lstStyle/>
+          <a:p>
+            <a:pPr indent="0" marL="0">
+              <a:buNone/>
+            </a:pPr>
+            <a:r>
+              <a:rPr lang="en-US" sz="1350" b="1" dirty="0">
+                <a:solidFill>
+                  <a:srgbClr val="2E8B7A"/>
+                </a:solidFill>
+                <a:latin typeface="Calibri" pitchFamily="34" charset="0"/>
+                <a:ea typeface="Calibri" pitchFamily="34" charset="-122"/>
+                <a:cs typeface="Calibri" pitchFamily="34" charset="-120"/>
+              </a:rPr>
+              <a:t>Native</a:t>
+            </a:r>
+            <a:endParaRPr lang="en-US" sz="1350" dirty="0"/>
+          </a:p>
+        </p:txBody>
+      </p:sp>
+      <p:sp>
+        <p:nvSpPr>
+          <p:cNvPr id="23" name="Text 21"/>
+          <p:cNvSpPr/>
+          <p:nvPr/>
+        </p:nvSpPr>
+        <p:spPr>
+          <a:xfrm>
+            <a:off x="2651760" y="4937760"/>
+            <a:ext cx="8595360" cy="384048"/>
+          </a:xfrm>
+          <a:prstGeom prst="rect">
+            <a:avLst/>
+          </a:prstGeom>
+          <a:noFill/>
+          <a:ln/>
+        </p:spPr>
+        <p:txBody>
+          <a:bodyPr wrap="square" lIns="0" tIns="0" rIns="0" bIns="0" rtlCol="0" anchor="ctr"/>
+          <a:lstStyle/>
+          <a:p>
+            <a:pPr indent="0" marL="0">
+              <a:buNone/>
+            </a:pPr>
+            <a:r>
+              <a:rPr lang="en-US" sz="1350" dirty="0">
+                <a:solidFill>
+                  <a:srgbClr val="5C6675"/>
+                </a:solidFill>
+                <a:latin typeface="Calibri" pitchFamily="34" charset="0"/>
+                <a:ea typeface="Calibri" pitchFamily="34" charset="-122"/>
+                <a:cs typeface="Calibri" pitchFamily="34" charset="-120"/>
+              </a:rPr>
+              <a:t>AWS Cost Explorer  ·  Azure Cost Management  ·  GCP Billing</a:t>
+            </a:r>
+            <a:endParaRPr lang="en-US" sz="1350" dirty="0"/>
+          </a:p>
+        </p:txBody>
+      </p:sp>
+      <p:sp>
+        <p:nvSpPr>
+          <p:cNvPr id="24" name="Text 22"/>
+          <p:cNvSpPr/>
+          <p:nvPr/>
+        </p:nvSpPr>
+        <p:spPr>
+          <a:xfrm>
+            <a:off x="877824" y="5349240"/>
+            <a:ext cx="1737360" cy="384048"/>
+          </a:xfrm>
+          <a:prstGeom prst="rect">
+            <a:avLst/>
+          </a:prstGeom>
+          <a:noFill/>
+          <a:ln/>
+        </p:spPr>
+        <p:txBody>
+          <a:bodyPr wrap="square" lIns="0" tIns="0" rIns="0" bIns="0" rtlCol="0" anchor="ctr"/>
+          <a:lstStyle/>
+          <a:p>
+            <a:pPr indent="0" marL="0">
+              <a:buNone/>
+            </a:pPr>
+            <a:r>
+              <a:rPr lang="en-US" sz="1350" b="1" dirty="0">
+                <a:solidFill>
+                  <a:srgbClr val="B87B18"/>
+                </a:solidFill>
+                <a:latin typeface="Calibri" pitchFamily="34" charset="0"/>
+                <a:ea typeface="Calibri" pitchFamily="34" charset="-122"/>
+                <a:cs typeface="Calibri" pitchFamily="34" charset="-120"/>
+              </a:rPr>
+              <a:t>Third-party</a:t>
+            </a:r>
+            <a:endParaRPr lang="en-US" sz="1350" dirty="0"/>
+          </a:p>
+        </p:txBody>
+      </p:sp>
+      <p:sp>
+        <p:nvSpPr>
+          <p:cNvPr id="25" name="Text 23"/>
+          <p:cNvSpPr/>
+          <p:nvPr/>
+        </p:nvSpPr>
+        <p:spPr>
+          <a:xfrm>
+            <a:off x="2651760" y="5349240"/>
+            <a:ext cx="8595360" cy="384048"/>
+          </a:xfrm>
+          <a:prstGeom prst="rect">
+            <a:avLst/>
+          </a:prstGeom>
+          <a:noFill/>
+          <a:ln/>
+        </p:spPr>
+        <p:txBody>
+          <a:bodyPr wrap="square" lIns="0" tIns="0" rIns="0" bIns="0" rtlCol="0" anchor="ctr"/>
+          <a:lstStyle/>
+          <a:p>
+            <a:pPr indent="0" marL="0">
+              <a:buNone/>
+            </a:pPr>
+            <a:r>
+              <a:rPr lang="en-US" sz="1350" dirty="0">
+                <a:solidFill>
+                  <a:srgbClr val="5C6675"/>
+                </a:solidFill>
+                <a:latin typeface="Calibri" pitchFamily="34" charset="0"/>
+                <a:ea typeface="Calibri" pitchFamily="34" charset="-122"/>
+                <a:cs typeface="Calibri" pitchFamily="34" charset="-120"/>
+              </a:rPr>
+              <a:t>CloudHealth  ·  Apptio  ·  Vantage  ·  nOps  ·  Finout  ·  CoreStack</a:t>
+            </a:r>
+            <a:endParaRPr lang="en-US" sz="1350" dirty="0"/>
+          </a:p>
+        </p:txBody>
+      </p:sp>
+      <p:sp>
+        <p:nvSpPr>
+          <p:cNvPr id="26" name="Text 24"/>
+          <p:cNvSpPr/>
+          <p:nvPr/>
+        </p:nvSpPr>
+        <p:spPr>
+          <a:xfrm>
+            <a:off x="877824" y="5760720"/>
+            <a:ext cx="1737360" cy="384048"/>
+          </a:xfrm>
+          <a:prstGeom prst="rect">
+            <a:avLst/>
+          </a:prstGeom>
+          <a:noFill/>
+          <a:ln/>
+        </p:spPr>
+        <p:txBody>
+          <a:bodyPr wrap="square" lIns="0" tIns="0" rIns="0" bIns="0" rtlCol="0" anchor="ctr"/>
+          <a:lstStyle/>
+          <a:p>
+            <a:pPr indent="0" marL="0">
+              <a:buNone/>
+            </a:pPr>
+            <a:r>
+              <a:rPr lang="en-US" sz="1350" b="1" dirty="0">
+                <a:solidFill>
+                  <a:srgbClr val="1B2430"/>
+                </a:solidFill>
+                <a:latin typeface="Calibri" pitchFamily="34" charset="0"/>
+                <a:ea typeface="Calibri" pitchFamily="34" charset="-122"/>
+                <a:cs typeface="Calibri" pitchFamily="34" charset="-120"/>
+              </a:rPr>
+              <a:t>Standard</a:t>
+            </a:r>
+            <a:endParaRPr lang="en-US" sz="1350" dirty="0"/>
+          </a:p>
+        </p:txBody>
+      </p:sp>
+      <p:sp>
+        <p:nvSpPr>
+          <p:cNvPr id="27" name="Text 25"/>
+          <p:cNvSpPr/>
+          <p:nvPr/>
+        </p:nvSpPr>
+        <p:spPr>
+          <a:xfrm>
+            <a:off x="2651760" y="5760720"/>
+            <a:ext cx="8595360" cy="384048"/>
+          </a:xfrm>
+          <a:prstGeom prst="rect">
+            <a:avLst/>
+          </a:prstGeom>
+          <a:noFill/>
+          <a:ln/>
+        </p:spPr>
+        <p:txBody>
+          <a:bodyPr wrap="square" lIns="0" tIns="0" rIns="0" bIns="0" rtlCol="0" anchor="ctr"/>
+          <a:lstStyle/>
+          <a:p>
+            <a:pPr indent="0" marL="0">
+              <a:buNone/>
+            </a:pPr>
+            <a:r>
+              <a:rPr lang="en-US" sz="1350" dirty="0">
+                <a:solidFill>
+                  <a:srgbClr val="5C6675"/>
+                </a:solidFill>
+                <a:latin typeface="Calibri" pitchFamily="34" charset="0"/>
+                <a:ea typeface="Calibri" pitchFamily="34" charset="-122"/>
+                <a:cs typeface="Calibri" pitchFamily="34" charset="-120"/>
+              </a:rPr>
+              <a:t>FOCUS-compliant platforms for multi-cloud reporting</a:t>
+            </a:r>
+            <a:endParaRPr lang="en-US" sz="1350" dirty="0"/>
+          </a:p>
+        </p:txBody>
+      </p:sp>
+    </p:spTree>
+  </p:cSld>
+  <p:clrMapOvr>
+    <a:masterClrMapping/>
+  </p:clrMapOvr>
+</p:sld>
+</file>
+
+<file path=ppt/slides/slide21.xml><?xml version="1.0" encoding="utf-8"?>
+<p:sld xmlns:a="http://schemas.openxmlformats.org/drawingml/2006/main" xmlns:r="http://schemas.openxmlformats.org/officeDocument/2006/relationships" xmlns:p="http://schemas.openxmlformats.org/presentationml/2006/main">
+  <p:cSld name="Slide 21">
+    <p:bg>
+      <p:bgPr>
+        <a:solidFill>
           <a:srgbClr val="141A22"/>
         </a:solidFill>
       </p:bgPr>
@@ -14583,9 +15926,9 @@
 </p:sld>
 </file>
 
-<file path=ppt/slides/slide21.xml><?xml version="1.0" encoding="utf-8"?>
+<file path=ppt/slides/slide22.xml><?xml version="1.0" encoding="utf-8"?>
 <p:sld xmlns:a="http://schemas.openxmlformats.org/drawingml/2006/main" xmlns:r="http://schemas.openxmlformats.org/officeDocument/2006/relationships" xmlns:p="http://schemas.openxmlformats.org/presentationml/2006/main">
-  <p:cSld name="Slide 21">
+  <p:cSld name="Slide 22">
     <p:bg>
       <p:bgPr>
         <a:solidFill>

</xml_diff>